<commit_message>
Replace Review II literature slides with one paper per slide
Co-Authored-By: Claude Opus 5.5 <noreply@anthropic.com>
Claude-Session: https://claude.ai/code/session_015D4bQVZNhTGUwEsTWPJArD
</commit_message>
<xml_diff>
--- a/submission/CEP_Review_II_AwaazSetu.pptx
+++ b/submission/CEP_Review_II_AwaazSetu.pptx
@@ -21075,7 +21075,7 @@
                 <a:cs typeface="Rockwell"/>
                 <a:sym typeface="Rockwell"/>
               </a:rPr>
-              <a:t>Literature Survey &amp; Findings : (Survey 1 of 4)</a:t>
+              <a:t>Literature Survey &amp; Findings : (Paper 1 of 4)</a:t>
             </a:r>
             <a:endParaRPr sz="2000" b="1" dirty="0">
               <a:solidFill>
@@ -21353,7 +21353,7 @@
                   </a:ext>
                 </a:extLst>
               </a:tr>
-              <a:tr h="1038050">
+              <a:tr h="2700000">
                 <a:tc>
                   <a:txBody>
                     <a:bodyPr/>
@@ -21377,7 +21377,7 @@
                         <a:buNone/>
                       </a:pPr>
                       <a:r>
-                        <a:rPr sz="1100" b="0">
+                        <a:rPr sz="1400" b="0">
                           <a:solidFill>
                             <a:srgbClr val="000000"/>
                           </a:solidFill>
@@ -21413,25 +21413,25 @@
                         <a:buNone/>
                       </a:pPr>
                       <a:r>
-                        <a:rPr sz="1000" b="0">
+                        <a:rPr sz="1300" b="0">
                           <a:solidFill>
                             <a:srgbClr val="000000"/>
                           </a:solidFill>
                           <a:latin typeface="Calibri"/>
                         </a:rPr>
-                        <a:t>Unpacking the role of volunteered geographic information in disaster management: focus on data quality</a:t>
+                        <a:t>Javed et al., 2024 — IndicVoices: Towards building an Inclusive Multilingual Speech Dataset for Indian Languages</a:t>
                       </a:r>
                       <a:endParaRPr sz="1800" u="none" strike="noStrike" cap="none"/>
                     </a:p>
                     <a:p>
                       <a:r>
-                        <a:rPr sz="1000" b="0">
+                        <a:rPr sz="1300" b="0">
                           <a:solidFill>
                             <a:srgbClr val="000000"/>
                           </a:solidFill>
                           <a:latin typeface="Calibri"/>
                         </a:rPr>
-                        <a:t>https://www.tandfonline.com/doi/full/10.1080/19475705.2023.2300825</a:t>
+                        <a:t>https://aclanthology.org/2024.findings-acl.639/</a:t>
                       </a:r>
                     </a:p>
                   </a:txBody>
@@ -21460,36 +21460,36 @@
                         <a:buNone/>
                       </a:pPr>
                       <a:r>
-                        <a:rPr sz="1000" b="0">
+                        <a:rPr sz="1300" b="0">
                           <a:solidFill>
                             <a:srgbClr val="000000"/>
                           </a:solidFill>
                           <a:latin typeface="Calibri"/>
                         </a:rPr>
-                        <a:t>Year: 2023</a:t>
+                        <a:t>Year: 2024</a:t>
                       </a:r>
                       <a:endParaRPr sz="1800" u="none" strike="noStrike" cap="none"/>
                     </a:p>
                     <a:p>
                       <a:r>
-                        <a:rPr sz="1000" b="0">
+                        <a:rPr sz="1300" b="0">
                           <a:solidFill>
                             <a:srgbClr val="000000"/>
                           </a:solidFill>
                           <a:latin typeface="Calibri"/>
                         </a:rPr>
-                        <a:t>Taylor &amp; Francis</a:t>
+                        <a:t>Findings of ACL 2024 (Association for Computational Linguistics), pp. 10740–10782</a:t>
                       </a:r>
                     </a:p>
                     <a:p>
                       <a:r>
-                        <a:rPr sz="1000" b="0">
+                        <a:rPr sz="1300" b="0">
                           <a:solidFill>
                             <a:srgbClr val="000000"/>
                           </a:solidFill>
                           <a:latin typeface="Calibri"/>
                         </a:rPr>
-                        <a:t>Review paper</a:t>
+                        <a:t>Dataset / technology paper</a:t>
                       </a:r>
                     </a:p>
                   </a:txBody>
@@ -21518,13 +21518,13 @@
                         <a:buChar char="•"/>
                       </a:pPr>
                       <a:r>
-                        <a:rPr sz="1000" b="0">
+                        <a:rPr sz="1300" b="0">
                           <a:solidFill>
                             <a:srgbClr val="000000"/>
                           </a:solidFill>
                           <a:latin typeface="Calibri"/>
                         </a:rPr>
-                        <a:t>VGI and citizen science are related but distinct concepts</a:t>
+                        <a:t>7,348 hours of natural speech: read (9%), extempore (74%) and conversational (17%)</a:t>
                       </a:r>
                       <a:endParaRPr sz="1800" u="none" strike="noStrike" cap="none" dirty="0"/>
                     </a:p>
@@ -21534,13 +21534,13 @@
                         <a:buChar char="•"/>
                       </a:pPr>
                       <a:r>
-                        <a:rPr sz="1000" b="0">
+                        <a:rPr sz="1300" b="0">
                           <a:solidFill>
                             <a:srgbClr val="000000"/>
                           </a:solidFill>
                           <a:latin typeface="Calibri"/>
                         </a:rPr>
-                        <a:t>Combined bibliometric and text-mining methodology</a:t>
+                        <a:t>16,237 speakers from 145 Indian districts covering 22 languages</a:t>
                       </a:r>
                     </a:p>
                     <a:p>
@@ -21549,13 +21549,13 @@
                         <a:buChar char="•"/>
                       </a:pPr>
                       <a:r>
-                        <a:rPr sz="1000" b="0">
+                        <a:rPr sz="1300" b="0">
                           <a:solidFill>
                             <a:srgbClr val="000000"/>
                           </a:solidFill>
                           <a:latin typeface="Calibri"/>
                         </a:rPr>
-                        <a:t>Five thematic clusters in data-quality literature</a:t>
+                        <a:t>1,639 hours already transcribed, a median of 73 hours per language</a:t>
                       </a:r>
                     </a:p>
                     <a:p>
@@ -21564,13 +21564,13 @@
                         <a:buChar char="•"/>
                       </a:pPr>
                       <a:r>
-                        <a:rPr sz="1000" b="0">
+                        <a:rPr sz="1300" b="0">
                           <a:solidFill>
                             <a:srgbClr val="000000"/>
                           </a:solidFill>
                           <a:latin typeface="Calibri"/>
                         </a:rPr>
-                        <a:t>VGI quality challenges mapped onto the PPRR disaster cycle</a:t>
+                        <a:t>Releases IndicASR, a speech recognition model supporting all 22 languages</a:t>
                       </a:r>
                     </a:p>
                   </a:txBody>
@@ -21579,464 +21579,6 @@
                 <a:extLst>
                   <a:ext uri="{0D108BD9-81ED-4DB2-BD59-A6C34878D82A}">
                     <a16:rowId xmlns:a16="http://schemas.microsoft.com/office/drawing/2014/main" val="10001"/>
-                  </a:ext>
-                </a:extLst>
-              </a:tr>
-              <a:tr h="1318300">
-                <a:tc>
-                  <a:txBody>
-                    <a:bodyPr/>
-                    <a:lstStyle/>
-                    <a:p>
-                      <a:pPr marL="0" marR="0" lvl="0" indent="0" algn="l" rtl="0">
-                        <a:lnSpc>
-                          <a:spcPct val="100000"/>
-                        </a:lnSpc>
-                        <a:spcBef>
-                          <a:spcPts val="0"/>
-                        </a:spcBef>
-                        <a:spcAft>
-                          <a:spcPts val="0"/>
-                        </a:spcAft>
-                        <a:buClr>
-                          <a:srgbClr val="000000"/>
-                        </a:buClr>
-                        <a:buSzPts val="1800"/>
-                        <a:buFont typeface="Arial"/>
-                        <a:buNone/>
-                      </a:pPr>
-                      <a:r>
-                        <a:rPr sz="1100" b="0">
-                          <a:solidFill>
-                            <a:srgbClr val="000000"/>
-                          </a:solidFill>
-                          <a:latin typeface="Calibri"/>
-                        </a:rPr>
-                        <a:t>2.</a:t>
-                      </a:r>
-                      <a:endParaRPr sz="1800"/>
-                    </a:p>
-                  </a:txBody>
-                  <a:tcPr marL="91450" marR="91450" marT="45725" marB="45725"/>
-                </a:tc>
-                <a:tc>
-                  <a:txBody>
-                    <a:bodyPr/>
-                    <a:lstStyle/>
-                    <a:p>
-                      <a:pPr marL="0" marR="0" lvl="0" indent="0" algn="l" rtl="0">
-                        <a:lnSpc>
-                          <a:spcPct val="100000"/>
-                        </a:lnSpc>
-                        <a:spcBef>
-                          <a:spcPts val="0"/>
-                        </a:spcBef>
-                        <a:spcAft>
-                          <a:spcPts val="0"/>
-                        </a:spcAft>
-                        <a:buClr>
-                          <a:srgbClr val="000000"/>
-                        </a:buClr>
-                        <a:buSzPts val="1800"/>
-                        <a:buFont typeface="Arial"/>
-                        <a:buNone/>
-                      </a:pPr>
-                      <a:r>
-                        <a:rPr sz="1000" b="0">
-                          <a:solidFill>
-                            <a:srgbClr val="000000"/>
-                          </a:solidFill>
-                          <a:latin typeface="Calibri"/>
-                        </a:rPr>
-                        <a:t>A method for assessing the credibility of volunteered geographic information in case of flood crisis</a:t>
-                      </a:r>
-                      <a:endParaRPr sz="1800"/>
-                    </a:p>
-                    <a:p>
-                      <a:r>
-                        <a:rPr sz="1000" b="0">
-                          <a:solidFill>
-                            <a:srgbClr val="000000"/>
-                          </a:solidFill>
-                          <a:latin typeface="Calibri"/>
-                        </a:rPr>
-                        <a:t>https://www.sciencedirect.com/science/article/pii/S1877050922011012</a:t>
-                      </a:r>
-                    </a:p>
-                  </a:txBody>
-                  <a:tcPr marL="91450" marR="91450" marT="45725" marB="45725"/>
-                </a:tc>
-                <a:tc>
-                  <a:txBody>
-                    <a:bodyPr/>
-                    <a:lstStyle/>
-                    <a:p>
-                      <a:pPr marL="0" marR="0" lvl="0" indent="0" algn="l" rtl="0">
-                        <a:lnSpc>
-                          <a:spcPct val="100000"/>
-                        </a:lnSpc>
-                        <a:spcBef>
-                          <a:spcPts val="0"/>
-                        </a:spcBef>
-                        <a:spcAft>
-                          <a:spcPts val="0"/>
-                        </a:spcAft>
-                        <a:buClr>
-                          <a:srgbClr val="000000"/>
-                        </a:buClr>
-                        <a:buSzPts val="1800"/>
-                        <a:buFont typeface="Arial"/>
-                        <a:buNone/>
-                      </a:pPr>
-                      <a:r>
-                        <a:rPr sz="1000" b="0">
-                          <a:solidFill>
-                            <a:srgbClr val="000000"/>
-                          </a:solidFill>
-                          <a:latin typeface="Calibri"/>
-                        </a:rPr>
-                        <a:t>Year: 2022</a:t>
-                      </a:r>
-                      <a:endParaRPr sz="1800" u="none" strike="noStrike" cap="none"/>
-                    </a:p>
-                    <a:p>
-                      <a:r>
-                        <a:rPr sz="1000" b="0">
-                          <a:solidFill>
-                            <a:srgbClr val="000000"/>
-                          </a:solidFill>
-                          <a:latin typeface="Calibri"/>
-                        </a:rPr>
-                        <a:t>ScienceDirect</a:t>
-                      </a:r>
-                    </a:p>
-                    <a:p>
-                      <a:r>
-                        <a:rPr sz="1000" b="0">
-                          <a:solidFill>
-                            <a:srgbClr val="000000"/>
-                          </a:solidFill>
-                          <a:latin typeface="Calibri"/>
-                        </a:rPr>
-                        <a:t>Technology paper</a:t>
-                      </a:r>
-                    </a:p>
-                  </a:txBody>
-                  <a:tcPr marL="91450" marR="91450" marT="45725" marB="45725"/>
-                </a:tc>
-                <a:tc>
-                  <a:txBody>
-                    <a:bodyPr/>
-                    <a:lstStyle/>
-                    <a:p>
-                      <a:pPr marL="114300" marR="0" lvl="0" indent="-114300" algn="l" rtl="0">
-                        <a:lnSpc>
-                          <a:spcPct val="100000"/>
-                        </a:lnSpc>
-                        <a:spcBef>
-                          <a:spcPts val="0"/>
-                        </a:spcBef>
-                        <a:spcAft>
-                          <a:spcPts val="0"/>
-                        </a:spcAft>
-                        <a:buClr>
-                          <a:srgbClr val="000000"/>
-                        </a:buClr>
-                        <a:buSzPts val="1800"/>
-                        <a:buFont typeface="Arial"/>
-                        <a:buChar char="•"/>
-                      </a:pPr>
-                      <a:r>
-                        <a:rPr sz="1000" b="0">
-                          <a:solidFill>
-                            <a:srgbClr val="000000"/>
-                          </a:solidFill>
-                          <a:latin typeface="Calibri"/>
-                        </a:rPr>
-                        <a:t>Score-based credibility model for text- and map-based VGI</a:t>
-                      </a:r>
-                      <a:endParaRPr sz="1800" u="none" strike="noStrike" cap="none"/>
-                    </a:p>
-                    <a:p>
-                      <a:pPr marL="114300" indent="-114300">
-                        <a:buFont typeface="Arial"/>
-                        <a:buChar char="•"/>
-                      </a:pPr>
-                      <a:r>
-                        <a:rPr sz="1000" b="0">
-                          <a:solidFill>
-                            <a:srgbClr val="000000"/>
-                          </a:solidFill>
-                          <a:latin typeface="Calibri"/>
-                        </a:rPr>
-                        <a:t>Uses distance, flood hazard and spatial clustering</a:t>
-                      </a:r>
-                    </a:p>
-                    <a:p>
-                      <a:pPr marL="114300" indent="-114300">
-                        <a:buFont typeface="Arial"/>
-                        <a:buChar char="•"/>
-                      </a:pPr>
-                      <a:r>
-                        <a:rPr sz="1000" b="0">
-                          <a:solidFill>
-                            <a:srgbClr val="000000"/>
-                          </a:solidFill>
-                          <a:latin typeface="Calibri"/>
-                        </a:rPr>
-                        <a:t>Validated on Ushahidi reports from the 2013 Brisbane flood</a:t>
-                      </a:r>
-                    </a:p>
-                    <a:p>
-                      <a:pPr marL="114300" indent="-114300">
-                        <a:buFont typeface="Arial"/>
-                        <a:buChar char="•"/>
-                      </a:pPr>
-                      <a:r>
-                        <a:rPr sz="1000" b="0">
-                          <a:solidFill>
-                            <a:srgbClr val="000000"/>
-                          </a:solidFill>
-                          <a:latin typeface="Calibri"/>
-                        </a:rPr>
-                        <a:t>Reports classed high/low credibility against ground truth</a:t>
-                      </a:r>
-                    </a:p>
-                  </a:txBody>
-                  <a:tcPr marL="91450" marR="91450" marT="45725" marB="45725"/>
-                </a:tc>
-                <a:extLst>
-                  <a:ext uri="{0D108BD9-81ED-4DB2-BD59-A6C34878D82A}">
-                    <a16:rowId xmlns:a16="http://schemas.microsoft.com/office/drawing/2014/main" val="10002"/>
-                  </a:ext>
-                </a:extLst>
-              </a:tr>
-              <a:tr h="859050">
-                <a:tc>
-                  <a:txBody>
-                    <a:bodyPr/>
-                    <a:lstStyle/>
-                    <a:p>
-                      <a:pPr marL="0" marR="0" lvl="0" indent="0" algn="l" rtl="0">
-                        <a:lnSpc>
-                          <a:spcPct val="100000"/>
-                        </a:lnSpc>
-                        <a:spcBef>
-                          <a:spcPts val="0"/>
-                        </a:spcBef>
-                        <a:spcAft>
-                          <a:spcPts val="0"/>
-                        </a:spcAft>
-                        <a:buClr>
-                          <a:srgbClr val="000000"/>
-                        </a:buClr>
-                        <a:buSzPts val="1800"/>
-                        <a:buFont typeface="Arial"/>
-                        <a:buNone/>
-                      </a:pPr>
-                      <a:r>
-                        <a:rPr sz="1100" b="0">
-                          <a:solidFill>
-                            <a:srgbClr val="000000"/>
-                          </a:solidFill>
-                          <a:latin typeface="Calibri"/>
-                        </a:rPr>
-                        <a:t>3.</a:t>
-                      </a:r>
-                      <a:endParaRPr sz="1800" u="none" strike="noStrike" cap="none"/>
-                    </a:p>
-                  </a:txBody>
-                  <a:tcPr marL="91450" marR="91450" marT="45725" marB="45725"/>
-                </a:tc>
-                <a:tc>
-                  <a:txBody>
-                    <a:bodyPr/>
-                    <a:lstStyle/>
-                    <a:p>
-                      <a:pPr marL="0" marR="0" lvl="0" indent="0" algn="l" rtl="0">
-                        <a:lnSpc>
-                          <a:spcPct val="100000"/>
-                        </a:lnSpc>
-                        <a:spcBef>
-                          <a:spcPts val="0"/>
-                        </a:spcBef>
-                        <a:spcAft>
-                          <a:spcPts val="0"/>
-                        </a:spcAft>
-                        <a:buClr>
-                          <a:srgbClr val="000000"/>
-                        </a:buClr>
-                        <a:buSzPts val="1800"/>
-                        <a:buFont typeface="Arial"/>
-                        <a:buNone/>
-                      </a:pPr>
-                      <a:r>
-                        <a:rPr sz="1000" b="0">
-                          <a:solidFill>
-                            <a:srgbClr val="000000"/>
-                          </a:solidFill>
-                          <a:latin typeface="Calibri"/>
-                        </a:rPr>
-                        <a:t>Analysis of Mumbai floods in recent years with crowdsourced data</a:t>
-                      </a:r>
-                      <a:endParaRPr sz="1800"/>
-                    </a:p>
-                    <a:p>
-                      <a:r>
-                        <a:rPr sz="1000" b="0">
-                          <a:solidFill>
-                            <a:srgbClr val="000000"/>
-                          </a:solidFill>
-                          <a:latin typeface="Calibri"/>
-                        </a:rPr>
-                        <a:t>https://www.sciencedirect.com/science/article/abs/pii/S2212095524000117</a:t>
-                      </a:r>
-                    </a:p>
-                  </a:txBody>
-                  <a:tcPr marL="91450" marR="91450" marT="45725" marB="45725"/>
-                </a:tc>
-                <a:tc>
-                  <a:txBody>
-                    <a:bodyPr/>
-                    <a:lstStyle/>
-                    <a:p>
-                      <a:pPr marL="0" marR="0" lvl="0" indent="0" algn="l" rtl="0">
-                        <a:lnSpc>
-                          <a:spcPct val="100000"/>
-                        </a:lnSpc>
-                        <a:spcBef>
-                          <a:spcPts val="0"/>
-                        </a:spcBef>
-                        <a:spcAft>
-                          <a:spcPts val="0"/>
-                        </a:spcAft>
-                        <a:buClr>
-                          <a:srgbClr val="000000"/>
-                        </a:buClr>
-                        <a:buSzPts val="1800"/>
-                        <a:buFont typeface="Arial"/>
-                        <a:buNone/>
-                      </a:pPr>
-                      <a:r>
-                        <a:rPr sz="1000" b="0">
-                          <a:solidFill>
-                            <a:srgbClr val="000000"/>
-                          </a:solidFill>
-                          <a:latin typeface="Calibri"/>
-                        </a:rPr>
-                        <a:t>Year: 2024</a:t>
-                      </a:r>
-                      <a:endParaRPr sz="1800" u="none" strike="noStrike" cap="none" dirty="0"/>
-                    </a:p>
-                    <a:p>
-                      <a:r>
-                        <a:rPr sz="1000" b="0">
-                          <a:solidFill>
-                            <a:srgbClr val="000000"/>
-                          </a:solidFill>
-                          <a:latin typeface="Calibri"/>
-                        </a:rPr>
-                        <a:t>ScienceDirect</a:t>
-                      </a:r>
-                    </a:p>
-                    <a:p>
-                      <a:r>
-                        <a:rPr sz="1000" b="0">
-                          <a:solidFill>
-                            <a:srgbClr val="000000"/>
-                          </a:solidFill>
-                          <a:latin typeface="Calibri"/>
-                        </a:rPr>
-                        <a:t>Technology paper</a:t>
-                      </a:r>
-                    </a:p>
-                  </a:txBody>
-                  <a:tcPr marL="91450" marR="91450" marT="45725" marB="45725"/>
-                </a:tc>
-                <a:tc>
-                  <a:txBody>
-                    <a:bodyPr/>
-                    <a:lstStyle/>
-                    <a:p>
-                      <a:pPr marL="114300" marR="0" lvl="0" indent="-114300" algn="l" rtl="0">
-                        <a:lnSpc>
-                          <a:spcPct val="100000"/>
-                        </a:lnSpc>
-                        <a:spcBef>
-                          <a:spcPts val="0"/>
-                        </a:spcBef>
-                        <a:spcAft>
-                          <a:spcPts val="0"/>
-                        </a:spcAft>
-                        <a:buClr>
-                          <a:srgbClr val="000000"/>
-                        </a:buClr>
-                        <a:buSzPts val="1800"/>
-                        <a:buFont typeface="Arial"/>
-                        <a:buChar char="•"/>
-                      </a:pPr>
-                      <a:r>
-                        <a:rPr sz="1000" b="0">
-                          <a:solidFill>
-                            <a:srgbClr val="000000"/>
-                          </a:solidFill>
-                          <a:latin typeface="Calibri"/>
-                        </a:rPr>
-                        <a:t>Urban flooding drivers and impacts</a:t>
-                      </a:r>
-                      <a:endParaRPr sz="1800" dirty="0"/>
-                    </a:p>
-                    <a:p>
-                      <a:pPr marL="114300" indent="-114300">
-                        <a:buFont typeface="Arial"/>
-                        <a:buChar char="•"/>
-                      </a:pPr>
-                      <a:r>
-                        <a:rPr sz="1000" b="0">
-                          <a:solidFill>
-                            <a:srgbClr val="000000"/>
-                          </a:solidFill>
-                          <a:latin typeface="Calibri"/>
-                        </a:rPr>
-                        <a:t>Gaps in traditional flood monitoring</a:t>
-                      </a:r>
-                    </a:p>
-                    <a:p>
-                      <a:pPr marL="114300" indent="-114300">
-                        <a:buFont typeface="Arial"/>
-                        <a:buChar char="•"/>
-                      </a:pPr>
-                      <a:r>
-                        <a:rPr sz="1000" b="0">
-                          <a:solidFill>
-                            <a:srgbClr val="000000"/>
-                          </a:solidFill>
-                          <a:latin typeface="Calibri"/>
-                        </a:rPr>
-                        <a:t>Crowdsourced data as a solution</a:t>
-                      </a:r>
-                    </a:p>
-                    <a:p>
-                      <a:pPr marL="114300" indent="-114300">
-                        <a:buFont typeface="Arial"/>
-                        <a:buChar char="•"/>
-                      </a:pPr>
-                      <a:r>
-                        <a:rPr sz="1000" b="0">
-                          <a:solidFill>
-                            <a:srgbClr val="000000"/>
-                          </a:solidFill>
-                          <a:latin typeface="Calibri"/>
-                        </a:rPr>
-                        <a:t>Choice and challenges of Twitter as a source</a:t>
-                      </a:r>
-                    </a:p>
-                  </a:txBody>
-                  <a:tcPr marL="91450" marR="91450" marT="45725" marB="45725"/>
-                </a:tc>
-                <a:extLst>
-                  <a:ext uri="{0D108BD9-81ED-4DB2-BD59-A6C34878D82A}">
-                    <a16:rowId xmlns:a16="http://schemas.microsoft.com/office/drawing/2014/main" val="10003"/>
                   </a:ext>
                 </a:extLst>
               </a:tr>
@@ -22227,6 +21769,75 @@
           </a:prstGeom>
         </p:spPr>
       </p:pic>
+      <p:sp>
+        <p:nvSpPr>
+          <p:cNvPr id="156" name="Rectangle 155"/>
+          <p:cNvSpPr/>
+          <p:nvPr/>
+        </p:nvSpPr>
+        <p:spPr>
+          <a:xfrm>
+            <a:off x="317999" y="5900000"/>
+            <a:ext cx="8454939" cy="560000"/>
+          </a:xfrm>
+          <a:prstGeom prst="rect">
+            <a:avLst/>
+          </a:prstGeom>
+          <a:solidFill>
+            <a:srgbClr val="EFCCBF"/>
+          </a:solidFill>
+          <a:ln>
+            <a:solidFill>
+              <a:srgbClr val="DD8047"/>
+            </a:solidFill>
+          </a:ln>
+          <a:effectLst/>
+        </p:spPr>
+        <p:style>
+          <a:lnRef idx="1">
+            <a:schemeClr val="accent1"/>
+          </a:lnRef>
+          <a:fillRef idx="3">
+            <a:schemeClr val="accent1"/>
+          </a:fillRef>
+          <a:effectRef idx="2">
+            <a:schemeClr val="accent1"/>
+          </a:effectRef>
+          <a:fontRef idx="minor">
+            <a:schemeClr val="lt1"/>
+          </a:fontRef>
+        </p:style>
+        <p:txBody>
+          <a:bodyPr rtlCol="0" anchor="ctr" wrap="square"/>
+          <a:lstStyle/>
+          <a:p>
+            <a:pPr algn="ctr" marL="0" indent="0">
+              <a:spcAft>
+                <a:spcPts val="0"/>
+              </a:spcAft>
+              <a:buNone/>
+            </a:pPr>
+            <a:r>
+              <a:rPr sz="1400" b="1">
+                <a:solidFill>
+                  <a:srgbClr val="000000"/>
+                </a:solidFill>
+                <a:latin typeface="Calibri"/>
+              </a:rPr>
+              <a:t>Use in AwaazSetu (M1 – Intake):</a:t>
+            </a:r>
+            <a:r>
+              <a:rPr sz="1400" b="0">
+                <a:solidFill>
+                  <a:srgbClr val="000000"/>
+                </a:solidFill>
+                <a:latin typeface="Calibri"/>
+              </a:rPr>
+              <a:t> an open Indian-language speech model for transcribing Marathi and Hindi voice notes.</a:t>
+            </a:r>
+          </a:p>
+        </p:txBody>
+      </p:sp>
     </p:spTree>
   </p:cSld>
   <p:clrMapOvr>
@@ -22301,7 +21912,7 @@
                 <a:cs typeface="Rockwell"/>
                 <a:sym typeface="Rockwell"/>
               </a:rPr>
-              <a:t>Literature Survey &amp; Findings : (Survey 2 of 4)</a:t>
+              <a:t>Literature Survey &amp; Findings : (Paper 2 of 4)</a:t>
             </a:r>
             <a:endParaRPr sz="2000" b="1" dirty="0">
               <a:solidFill>
@@ -22579,7 +22190,7 @@
                   </a:ext>
                 </a:extLst>
               </a:tr>
-              <a:tr h="1038050">
+              <a:tr h="2700000">
                 <a:tc>
                   <a:txBody>
                     <a:bodyPr/>
@@ -22603,13 +22214,13 @@
                         <a:buNone/>
                       </a:pPr>
                       <a:r>
-                        <a:rPr sz="1100" b="0">
+                        <a:rPr sz="1400" b="0">
                           <a:solidFill>
                             <a:srgbClr val="000000"/>
                           </a:solidFill>
                           <a:latin typeface="Calibri"/>
                         </a:rPr>
-                        <a:t>1.</a:t>
+                        <a:t>2.</a:t>
                       </a:r>
                       <a:endParaRPr sz="1600" dirty="0"/>
                     </a:p>
@@ -22639,25 +22250,25 @@
                         <a:buNone/>
                       </a:pPr>
                       <a:r>
-                        <a:rPr sz="1000" b="0">
+                        <a:rPr sz="1300" b="0">
                           <a:solidFill>
                             <a:srgbClr val="000000"/>
                           </a:solidFill>
                           <a:latin typeface="Calibri"/>
                         </a:rPr>
-                        <a:t>Opportunities for Crowdsourcing in Urban Flood Monitoring</a:t>
+                        <a:t>Dursunoğlu et al., 2026 — Designing a Human-in-the-Loop AI System for Incident Consolidation and Severity-Aware Triage in Emergency Call Centers</a:t>
                       </a:r>
                       <a:endParaRPr sz="1800" u="none" strike="noStrike" cap="none"/>
                     </a:p>
                     <a:p>
                       <a:r>
-                        <a:rPr sz="1000" b="0">
+                        <a:rPr sz="1300" b="0">
                           <a:solidFill>
                             <a:srgbClr val="000000"/>
                           </a:solidFill>
                           <a:latin typeface="Calibri"/>
                         </a:rPr>
-                        <a:t>https://doi.org/10.1016/j.envsoft.2021.105124</a:t>
+                        <a:t>https://doi.org/10.59297/g2fhn369</a:t>
                       </a:r>
                     </a:p>
                   </a:txBody>
@@ -22686,25 +22297,36 @@
                         <a:buNone/>
                       </a:pPr>
                       <a:r>
-                        <a:rPr sz="1000" b="0">
+                        <a:rPr sz="1300" b="0">
                           <a:solidFill>
                             <a:srgbClr val="000000"/>
                           </a:solidFill>
                           <a:latin typeface="Calibri"/>
                         </a:rPr>
-                        <a:t>2021</a:t>
+                        <a:t>Year: 2026</a:t>
                       </a:r>
                       <a:endParaRPr sz="1800" u="none" strike="noStrike" cap="none"/>
                     </a:p>
                     <a:p>
                       <a:r>
-                        <a:rPr sz="1000" b="0">
+                        <a:rPr sz="1300" b="0">
                           <a:solidFill>
                             <a:srgbClr val="000000"/>
                           </a:solidFill>
                           <a:latin typeface="Calibri"/>
                         </a:rPr>
-                        <a:t>Environmental Modelling &amp; Software (Elsevier)</a:t>
+                        <a:t>Proceedings of the International ISCRAM Conference, Vol. 23</a:t>
+                      </a:r>
+                    </a:p>
+                    <a:p>
+                      <a:r>
+                        <a:rPr sz="1300" b="0">
+                          <a:solidFill>
+                            <a:srgbClr val="000000"/>
+                          </a:solidFill>
+                          <a:latin typeface="Calibri"/>
+                        </a:rPr>
+                        <a:t>Technology paper</a:t>
                       </a:r>
                     </a:p>
                   </a:txBody>
@@ -22733,13 +22355,13 @@
                         <a:buChar char="•"/>
                       </a:pPr>
                       <a:r>
-                        <a:rPr sz="1000" b="0">
+                        <a:rPr sz="1300" b="0">
                           <a:solidFill>
                             <a:srgbClr val="000000"/>
                           </a:solidFill>
                           <a:latin typeface="Calibri"/>
                         </a:rPr>
-                        <a:t>Reviews crowdsourced flood-monitoring sources</a:t>
+                        <a:t>Fully automated decisions are inappropriate in high-stakes emergencies; operators stay in control</a:t>
                       </a:r>
                       <a:endParaRPr sz="1800" u="none" strike="noStrike" cap="none" dirty="0"/>
                     </a:p>
@@ -22749,13 +22371,13 @@
                         <a:buChar char="•"/>
                       </a:pPr>
                       <a:r>
-                        <a:rPr sz="1000" b="0">
+                        <a:rPr sz="1300" b="0">
                           <a:solidFill>
                             <a:srgbClr val="000000"/>
                           </a:solidFill>
                           <a:latin typeface="Calibri"/>
                         </a:rPr>
-                        <a:t>Examines webcams, social media and citizen science</a:t>
+                        <a:t>Pipeline: speech-to-text → NLP → probabilistic severity → spatial-semantic clustering</a:t>
                       </a:r>
                     </a:p>
                     <a:p>
@@ -22764,13 +22386,13 @@
                         <a:buChar char="•"/>
                       </a:pPr>
                       <a:r>
-                        <a:rPr sz="1000" b="0">
+                        <a:rPr sz="1300" b="0">
                           <a:solidFill>
                             <a:srgbClr val="000000"/>
                           </a:solidFill>
                           <a:latin typeface="Calibri"/>
                         </a:rPr>
-                        <a:t>Shows potential for fine-scale flood monitoring</a:t>
+                        <a:t>Consolidates duplicate incident reports and adds real-time geospatial awareness</a:t>
                       </a:r>
                     </a:p>
                     <a:p>
@@ -22779,13 +22401,13 @@
                         <a:buChar char="•"/>
                       </a:pPr>
                       <a:r>
-                        <a:rPr sz="1000" b="0">
+                        <a:rPr sz="1300" b="0">
                           <a:solidFill>
                             <a:srgbClr val="000000"/>
                           </a:solidFill>
                           <a:latin typeface="Calibri"/>
                         </a:rPr>
-                        <a:t>Identifies data quality and integration challenges</a:t>
+                        <a:t>Synthetic surge evaluation: promising classification with calibrated confidence</a:t>
                       </a:r>
                     </a:p>
                   </a:txBody>
@@ -22794,442 +22416,6 @@
                 <a:extLst>
                   <a:ext uri="{0D108BD9-81ED-4DB2-BD59-A6C34878D82A}">
                     <a16:rowId xmlns:a16="http://schemas.microsoft.com/office/drawing/2014/main" val="10001"/>
-                  </a:ext>
-                </a:extLst>
-              </a:tr>
-              <a:tr h="1318300">
-                <a:tc>
-                  <a:txBody>
-                    <a:bodyPr/>
-                    <a:lstStyle/>
-                    <a:p>
-                      <a:pPr marL="0" marR="0" lvl="0" indent="0" algn="l" rtl="0">
-                        <a:lnSpc>
-                          <a:spcPct val="100000"/>
-                        </a:lnSpc>
-                        <a:spcBef>
-                          <a:spcPts val="0"/>
-                        </a:spcBef>
-                        <a:spcAft>
-                          <a:spcPts val="0"/>
-                        </a:spcAft>
-                        <a:buClr>
-                          <a:srgbClr val="000000"/>
-                        </a:buClr>
-                        <a:buSzPts val="1800"/>
-                        <a:buFont typeface="Arial"/>
-                        <a:buNone/>
-                      </a:pPr>
-                      <a:r>
-                        <a:rPr sz="1100" b="0">
-                          <a:solidFill>
-                            <a:srgbClr val="000000"/>
-                          </a:solidFill>
-                          <a:latin typeface="Calibri"/>
-                        </a:rPr>
-                        <a:t>2.</a:t>
-                      </a:r>
-                      <a:endParaRPr sz="1800"/>
-                    </a:p>
-                  </a:txBody>
-                  <a:tcPr marL="91450" marR="91450" marT="45725" marB="45725"/>
-                </a:tc>
-                <a:tc>
-                  <a:txBody>
-                    <a:bodyPr/>
-                    <a:lstStyle/>
-                    <a:p>
-                      <a:pPr marL="0" marR="0" lvl="0" indent="0" algn="l" rtl="0">
-                        <a:lnSpc>
-                          <a:spcPct val="100000"/>
-                        </a:lnSpc>
-                        <a:spcBef>
-                          <a:spcPts val="0"/>
-                        </a:spcBef>
-                        <a:spcAft>
-                          <a:spcPts val="0"/>
-                        </a:spcAft>
-                        <a:buClr>
-                          <a:srgbClr val="000000"/>
-                        </a:buClr>
-                        <a:buSzPts val="1800"/>
-                        <a:buFont typeface="Arial"/>
-                        <a:buNone/>
-                      </a:pPr>
-                      <a:r>
-                        <a:rPr sz="1000" b="0">
-                          <a:solidFill>
-                            <a:srgbClr val="000000"/>
-                          </a:solidFill>
-                          <a:latin typeface="Calibri"/>
-                        </a:rPr>
-                        <a:t>Integrating User-Generated Content to Track Urban Flooding Hotspots and Foster Emergency Management: A Case Study in Central China</a:t>
-                      </a:r>
-                      <a:endParaRPr sz="1800"/>
-                    </a:p>
-                    <a:p>
-                      <a:r>
-                        <a:rPr sz="1000" b="0">
-                          <a:solidFill>
-                            <a:srgbClr val="000000"/>
-                          </a:solidFill>
-                          <a:latin typeface="Calibri"/>
-                        </a:rPr>
-                        <a:t>https://doi.org/10.1111/tgis.12836</a:t>
-                      </a:r>
-                    </a:p>
-                  </a:txBody>
-                  <a:tcPr marL="91450" marR="91450" marT="45725" marB="45725"/>
-                </a:tc>
-                <a:tc>
-                  <a:txBody>
-                    <a:bodyPr/>
-                    <a:lstStyle/>
-                    <a:p>
-                      <a:pPr marL="0" marR="0" lvl="0" indent="0" algn="l" rtl="0">
-                        <a:lnSpc>
-                          <a:spcPct val="100000"/>
-                        </a:lnSpc>
-                        <a:spcBef>
-                          <a:spcPts val="0"/>
-                        </a:spcBef>
-                        <a:spcAft>
-                          <a:spcPts val="0"/>
-                        </a:spcAft>
-                        <a:buClr>
-                          <a:srgbClr val="000000"/>
-                        </a:buClr>
-                        <a:buSzPts val="1800"/>
-                        <a:buFont typeface="Arial"/>
-                        <a:buNone/>
-                      </a:pPr>
-                      <a:r>
-                        <a:rPr sz="1000" b="0">
-                          <a:solidFill>
-                            <a:srgbClr val="000000"/>
-                          </a:solidFill>
-                          <a:latin typeface="Calibri"/>
-                        </a:rPr>
-                        <a:t>2021</a:t>
-                      </a:r>
-                      <a:endParaRPr sz="1800" u="none" strike="noStrike" cap="none"/>
-                    </a:p>
-                    <a:p>
-                      <a:r>
-                        <a:rPr sz="1000" b="0">
-                          <a:solidFill>
-                            <a:srgbClr val="000000"/>
-                          </a:solidFill>
-                          <a:latin typeface="Calibri"/>
-                        </a:rPr>
-                        <a:t>Transactions in GIS (Wiley)</a:t>
-                      </a:r>
-                    </a:p>
-                  </a:txBody>
-                  <a:tcPr marL="91450" marR="91450" marT="45725" marB="45725"/>
-                </a:tc>
-                <a:tc>
-                  <a:txBody>
-                    <a:bodyPr/>
-                    <a:lstStyle/>
-                    <a:p>
-                      <a:pPr marL="114300" marR="0" lvl="0" indent="-114300" algn="l" rtl="0">
-                        <a:lnSpc>
-                          <a:spcPct val="100000"/>
-                        </a:lnSpc>
-                        <a:spcBef>
-                          <a:spcPts val="0"/>
-                        </a:spcBef>
-                        <a:spcAft>
-                          <a:spcPts val="0"/>
-                        </a:spcAft>
-                        <a:buClr>
-                          <a:srgbClr val="000000"/>
-                        </a:buClr>
-                        <a:buSzPts val="1800"/>
-                        <a:buFont typeface="Arial"/>
-                        <a:buChar char="•"/>
-                      </a:pPr>
-                      <a:r>
-                        <a:rPr sz="1000" b="0">
-                          <a:solidFill>
-                            <a:srgbClr val="000000"/>
-                          </a:solidFill>
-                          <a:latin typeface="Calibri"/>
-                        </a:rPr>
-                        <a:t>Uses UGC to identify flood hotspots</a:t>
-                      </a:r>
-                      <a:endParaRPr sz="1800" u="none" strike="noStrike" cap="none"/>
-                    </a:p>
-                    <a:p>
-                      <a:pPr marL="114300" indent="-114300">
-                        <a:buFont typeface="Arial"/>
-                        <a:buChar char="•"/>
-                      </a:pPr>
-                      <a:r>
-                        <a:rPr sz="1000" b="0">
-                          <a:solidFill>
-                            <a:srgbClr val="000000"/>
-                          </a:solidFill>
-                          <a:latin typeface="Calibri"/>
-                        </a:rPr>
-                        <a:t>Applies crawlers, NLP and geographic visualisation</a:t>
-                      </a:r>
-                    </a:p>
-                    <a:p>
-                      <a:pPr marL="114300" indent="-114300">
-                        <a:buFont typeface="Arial"/>
-                        <a:buChar char="•"/>
-                      </a:pPr>
-                      <a:r>
-                        <a:rPr sz="1000" b="0">
-                          <a:solidFill>
-                            <a:srgbClr val="000000"/>
-                          </a:solidFill>
-                          <a:latin typeface="Calibri"/>
-                        </a:rPr>
-                        <a:t>Validates with water level, DEM and rainfall</a:t>
-                      </a:r>
-                    </a:p>
-                    <a:p>
-                      <a:pPr marL="114300" indent="-114300">
-                        <a:buFont typeface="Arial"/>
-                        <a:buChar char="•"/>
-                      </a:pPr>
-                      <a:r>
-                        <a:rPr sz="1000" b="0">
-                          <a:solidFill>
-                            <a:srgbClr val="000000"/>
-                          </a:solidFill>
-                          <a:latin typeface="Calibri"/>
-                        </a:rPr>
-                        <a:t>Supports flood emergency management</a:t>
-                      </a:r>
-                    </a:p>
-                  </a:txBody>
-                  <a:tcPr marL="91450" marR="91450" marT="45725" marB="45725"/>
-                </a:tc>
-                <a:extLst>
-                  <a:ext uri="{0D108BD9-81ED-4DB2-BD59-A6C34878D82A}">
-                    <a16:rowId xmlns:a16="http://schemas.microsoft.com/office/drawing/2014/main" val="10002"/>
-                  </a:ext>
-                </a:extLst>
-              </a:tr>
-              <a:tr h="859050">
-                <a:tc>
-                  <a:txBody>
-                    <a:bodyPr/>
-                    <a:lstStyle/>
-                    <a:p>
-                      <a:pPr marL="0" marR="0" lvl="0" indent="0" algn="l" rtl="0">
-                        <a:lnSpc>
-                          <a:spcPct val="100000"/>
-                        </a:lnSpc>
-                        <a:spcBef>
-                          <a:spcPts val="0"/>
-                        </a:spcBef>
-                        <a:spcAft>
-                          <a:spcPts val="0"/>
-                        </a:spcAft>
-                        <a:buClr>
-                          <a:srgbClr val="000000"/>
-                        </a:buClr>
-                        <a:buSzPts val="1800"/>
-                        <a:buFont typeface="Arial"/>
-                        <a:buNone/>
-                      </a:pPr>
-                      <a:r>
-                        <a:rPr sz="1100" b="0">
-                          <a:solidFill>
-                            <a:srgbClr val="000000"/>
-                          </a:solidFill>
-                          <a:latin typeface="Calibri"/>
-                        </a:rPr>
-                        <a:t>3.</a:t>
-                      </a:r>
-                      <a:endParaRPr sz="1800" u="none" strike="noStrike" cap="none"/>
-                    </a:p>
-                  </a:txBody>
-                  <a:tcPr marL="91450" marR="91450" marT="45725" marB="45725"/>
-                </a:tc>
-                <a:tc>
-                  <a:txBody>
-                    <a:bodyPr/>
-                    <a:lstStyle/>
-                    <a:p>
-                      <a:pPr marL="0" marR="0" lvl="0" indent="0" algn="l" rtl="0">
-                        <a:lnSpc>
-                          <a:spcPct val="100000"/>
-                        </a:lnSpc>
-                        <a:spcBef>
-                          <a:spcPts val="0"/>
-                        </a:spcBef>
-                        <a:spcAft>
-                          <a:spcPts val="0"/>
-                        </a:spcAft>
-                        <a:buClr>
-                          <a:srgbClr val="000000"/>
-                        </a:buClr>
-                        <a:buSzPts val="1800"/>
-                        <a:buFont typeface="Arial"/>
-                        <a:buNone/>
-                      </a:pPr>
-                      <a:r>
-                        <a:rPr sz="1000" b="0">
-                          <a:solidFill>
-                            <a:srgbClr val="000000"/>
-                          </a:solidFill>
-                          <a:latin typeface="Calibri"/>
-                        </a:rPr>
-                        <a:t>Quality Assessment of Crowdsourced Social Media Data for Urban Flood Management</a:t>
-                      </a:r>
-                      <a:endParaRPr sz="1800"/>
-                    </a:p>
-                    <a:p>
-                      <a:r>
-                        <a:rPr sz="1000" b="0">
-                          <a:solidFill>
-                            <a:srgbClr val="000000"/>
-                          </a:solidFill>
-                          <a:latin typeface="Calibri"/>
-                        </a:rPr>
-                        <a:t>https://doi.org/10.1016/j.compenvurbsys.2021.101690</a:t>
-                      </a:r>
-                    </a:p>
-                  </a:txBody>
-                  <a:tcPr marL="91450" marR="91450" marT="45725" marB="45725"/>
-                </a:tc>
-                <a:tc>
-                  <a:txBody>
-                    <a:bodyPr/>
-                    <a:lstStyle/>
-                    <a:p>
-                      <a:pPr marL="0" marR="0" lvl="0" indent="0" algn="l" rtl="0">
-                        <a:lnSpc>
-                          <a:spcPct val="100000"/>
-                        </a:lnSpc>
-                        <a:spcBef>
-                          <a:spcPts val="0"/>
-                        </a:spcBef>
-                        <a:spcAft>
-                          <a:spcPts val="0"/>
-                        </a:spcAft>
-                        <a:buClr>
-                          <a:srgbClr val="000000"/>
-                        </a:buClr>
-                        <a:buSzPts val="1800"/>
-                        <a:buFont typeface="Arial"/>
-                        <a:buNone/>
-                      </a:pPr>
-                      <a:r>
-                        <a:rPr sz="1000" b="0">
-                          <a:solidFill>
-                            <a:srgbClr val="000000"/>
-                          </a:solidFill>
-                          <a:latin typeface="Calibri"/>
-                        </a:rPr>
-                        <a:t>2021</a:t>
-                      </a:r>
-                      <a:endParaRPr sz="1800" u="none" strike="noStrike" cap="none" dirty="0"/>
-                    </a:p>
-                    <a:p>
-                      <a:r>
-                        <a:rPr sz="1000" b="0">
-                          <a:solidFill>
-                            <a:srgbClr val="000000"/>
-                          </a:solidFill>
-                          <a:latin typeface="Calibri"/>
-                        </a:rPr>
-                        <a:t>Computers, Environment and Urban Systems (Elsevier)</a:t>
-                      </a:r>
-                    </a:p>
-                  </a:txBody>
-                  <a:tcPr marL="91450" marR="91450" marT="45725" marB="45725"/>
-                </a:tc>
-                <a:tc>
-                  <a:txBody>
-                    <a:bodyPr/>
-                    <a:lstStyle/>
-                    <a:p>
-                      <a:pPr marL="114300" marR="0" lvl="0" indent="-114300" algn="l" rtl="0">
-                        <a:lnSpc>
-                          <a:spcPct val="100000"/>
-                        </a:lnSpc>
-                        <a:spcBef>
-                          <a:spcPts val="0"/>
-                        </a:spcBef>
-                        <a:spcAft>
-                          <a:spcPts val="0"/>
-                        </a:spcAft>
-                        <a:buClr>
-                          <a:srgbClr val="000000"/>
-                        </a:buClr>
-                        <a:buSzPts val="1800"/>
-                        <a:buFont typeface="Arial"/>
-                        <a:buChar char="•"/>
-                      </a:pPr>
-                      <a:r>
-                        <a:rPr sz="1000" b="0">
-                          <a:solidFill>
-                            <a:srgbClr val="000000"/>
-                          </a:solidFill>
-                          <a:latin typeface="Calibri"/>
-                        </a:rPr>
-                        <a:t>Assesses quality of crowdsourced data</a:t>
-                      </a:r>
-                      <a:endParaRPr sz="1800" dirty="0"/>
-                    </a:p>
-                    <a:p>
-                      <a:pPr marL="114300" indent="-114300">
-                        <a:buFont typeface="Arial"/>
-                        <a:buChar char="•"/>
-                      </a:pPr>
-                      <a:r>
-                        <a:rPr sz="1000" b="0">
-                          <a:solidFill>
-                            <a:srgbClr val="000000"/>
-                          </a:solidFill>
-                          <a:latin typeface="Calibri"/>
-                        </a:rPr>
-                        <a:t>Uses flood-related Twitter data</a:t>
-                      </a:r>
-                    </a:p>
-                    <a:p>
-                      <a:pPr marL="114300" indent="-114300">
-                        <a:buFont typeface="Arial"/>
-                        <a:buChar char="•"/>
-                      </a:pPr>
-                      <a:r>
-                        <a:rPr sz="1000" b="0">
-                          <a:solidFill>
-                            <a:srgbClr val="000000"/>
-                          </a:solidFill>
-                          <a:latin typeface="Calibri"/>
-                        </a:rPr>
-                        <a:t>Applies logistic regression and fuzzy logic</a:t>
-                      </a:r>
-                    </a:p>
-                    <a:p>
-                      <a:pPr marL="114300" indent="-114300">
-                        <a:buFont typeface="Arial"/>
-                        <a:buChar char="•"/>
-                      </a:pPr>
-                      <a:r>
-                        <a:rPr sz="1000" b="0">
-                          <a:solidFill>
-                            <a:srgbClr val="000000"/>
-                          </a:solidFill>
-                          <a:latin typeface="Calibri"/>
-                        </a:rPr>
-                        <a:t>Estimates uncertainty in social media observations</a:t>
-                      </a:r>
-                    </a:p>
-                  </a:txBody>
-                  <a:tcPr marL="91450" marR="91450" marT="45725" marB="45725"/>
-                </a:tc>
-                <a:extLst>
-                  <a:ext uri="{0D108BD9-81ED-4DB2-BD59-A6C34878D82A}">
-                    <a16:rowId xmlns:a16="http://schemas.microsoft.com/office/drawing/2014/main" val="10003"/>
                   </a:ext>
                 </a:extLst>
               </a:tr>
@@ -23420,6 +22606,75 @@
           </a:prstGeom>
         </p:spPr>
       </p:pic>
+      <p:sp>
+        <p:nvSpPr>
+          <p:cNvPr id="156" name="Rectangle 155"/>
+          <p:cNvSpPr/>
+          <p:nvPr/>
+        </p:nvSpPr>
+        <p:spPr>
+          <a:xfrm>
+            <a:off x="317999" y="5900000"/>
+            <a:ext cx="8454939" cy="560000"/>
+          </a:xfrm>
+          <a:prstGeom prst="rect">
+            <a:avLst/>
+          </a:prstGeom>
+          <a:solidFill>
+            <a:srgbClr val="EFCCBF"/>
+          </a:solidFill>
+          <a:ln>
+            <a:solidFill>
+              <a:srgbClr val="DD8047"/>
+            </a:solidFill>
+          </a:ln>
+          <a:effectLst/>
+        </p:spPr>
+        <p:style>
+          <a:lnRef idx="1">
+            <a:schemeClr val="accent1"/>
+          </a:lnRef>
+          <a:fillRef idx="3">
+            <a:schemeClr val="accent1"/>
+          </a:fillRef>
+          <a:effectRef idx="2">
+            <a:schemeClr val="accent1"/>
+          </a:effectRef>
+          <a:fontRef idx="minor">
+            <a:schemeClr val="lt1"/>
+          </a:fontRef>
+        </p:style>
+        <p:txBody>
+          <a:bodyPr rtlCol="0" anchor="ctr" wrap="square"/>
+          <a:lstStyle/>
+          <a:p>
+            <a:pPr algn="ctr" marL="0" indent="0">
+              <a:spcAft>
+                <a:spcPts val="0"/>
+              </a:spcAft>
+              <a:buNone/>
+            </a:pPr>
+            <a:r>
+              <a:rPr sz="1400" b="1">
+                <a:solidFill>
+                  <a:srgbClr val="000000"/>
+                </a:solidFill>
+                <a:latin typeface="Calibri"/>
+              </a:rPr>
+              <a:t>Use in AwaazSetu (M2 – Triage):</a:t>
+            </a:r>
+            <a:r>
+              <a:rPr sz="1400" b="0">
+                <a:solidFill>
+                  <a:srgbClr val="000000"/>
+                </a:solidFill>
+                <a:latin typeface="Calibri"/>
+              </a:rPr>
+              <a:t> explained severity scoring, duplicate merging and coordinator verification of every incident.</a:t>
+            </a:r>
+          </a:p>
+        </p:txBody>
+      </p:sp>
     </p:spTree>
   </p:cSld>
   <p:clrMapOvr>
@@ -23494,7 +22749,7 @@
                 <a:cs typeface="Rockwell"/>
                 <a:sym typeface="Rockwell"/>
               </a:rPr>
-              <a:t>Literature Survey &amp; Findings : (Survey 3 of 4)</a:t>
+              <a:t>Literature Survey &amp; Findings : (Paper 3 of 4)</a:t>
             </a:r>
             <a:endParaRPr sz="2000" b="1" dirty="0">
               <a:solidFill>
@@ -23772,7 +23027,7 @@
                   </a:ext>
                 </a:extLst>
               </a:tr>
-              <a:tr h="1038050">
+              <a:tr h="2700000">
                 <a:tc>
                   <a:txBody>
                     <a:bodyPr/>
@@ -23796,13 +23051,13 @@
                         <a:buNone/>
                       </a:pPr>
                       <a:r>
-                        <a:rPr sz="1100" b="0">
+                        <a:rPr sz="1400" b="0">
                           <a:solidFill>
                             <a:srgbClr val="000000"/>
                           </a:solidFill>
                           <a:latin typeface="Calibri"/>
                         </a:rPr>
-                        <a:t>1.</a:t>
+                        <a:t>3.</a:t>
                       </a:r>
                       <a:endParaRPr sz="1600" dirty="0"/>
                     </a:p>
@@ -23832,25 +23087,25 @@
                         <a:buNone/>
                       </a:pPr>
                       <a:r>
-                        <a:rPr sz="1000" b="0">
+                        <a:rPr sz="1300" b="0">
                           <a:solidFill>
                             <a:srgbClr val="000000"/>
                           </a:solidFill>
                           <a:latin typeface="Calibri"/>
                         </a:rPr>
-                        <a:t>Deep Learning Methods for Flood Mapping</a:t>
+                        <a:t>Hu et al., 2023 — Geo-knowledge-guided GPT models improve the extraction of location descriptions from disaster-related social media messages</a:t>
                       </a:r>
                       <a:endParaRPr sz="1800" u="none" strike="noStrike" cap="none"/>
                     </a:p>
                     <a:p>
                       <a:r>
-                        <a:rPr sz="1000" b="0">
+                        <a:rPr sz="1300" b="0">
                           <a:solidFill>
                             <a:srgbClr val="000000"/>
                           </a:solidFill>
                           <a:latin typeface="Calibri"/>
                         </a:rPr>
-                        <a:t>https://hess.copernicus.org/articles/26/4345/2022/</a:t>
+                        <a:t>https://doi.org/10.1080/13658816.2023.2266495</a:t>
                       </a:r>
                     </a:p>
                   </a:txBody>
@@ -23879,25 +23134,36 @@
                         <a:buNone/>
                       </a:pPr>
                       <a:r>
-                        <a:rPr sz="1000" b="0">
+                        <a:rPr sz="1300" b="0">
                           <a:solidFill>
                             <a:srgbClr val="000000"/>
                           </a:solidFill>
                           <a:latin typeface="Calibri"/>
                         </a:rPr>
-                        <a:t>26 Aug 2022</a:t>
+                        <a:t>Year: 2023</a:t>
                       </a:r>
                       <a:endParaRPr sz="1800" u="none" strike="noStrike" cap="none"/>
                     </a:p>
                     <a:p>
                       <a:r>
-                        <a:rPr sz="1000" b="0">
+                        <a:rPr sz="1300" b="0">
                           <a:solidFill>
                             <a:srgbClr val="000000"/>
                           </a:solidFill>
                           <a:latin typeface="Calibri"/>
                         </a:rPr>
-                        <a:t>Hydrology and Earth System Sciences (Copernicus)</a:t>
+                        <a:t>International Journal of Geographical Information Science (Taylor &amp; Francis)</a:t>
+                      </a:r>
+                    </a:p>
+                    <a:p>
+                      <a:r>
+                        <a:rPr sz="1300" b="0">
+                          <a:solidFill>
+                            <a:srgbClr val="000000"/>
+                          </a:solidFill>
+                          <a:latin typeface="Calibri"/>
+                        </a:rPr>
+                        <a:t>Technology paper</a:t>
                       </a:r>
                     </a:p>
                   </a:txBody>
@@ -23926,13 +23192,13 @@
                         <a:buChar char="•"/>
                       </a:pPr>
                       <a:r>
-                        <a:rPr sz="1000" b="0">
+                        <a:rPr sz="1300" b="0">
                           <a:solidFill>
                             <a:srgbClr val="000000"/>
                           </a:solidFill>
                           <a:latin typeface="Calibri"/>
                         </a:rPr>
-                        <a:t>Reviewed 58 studies using CNNs and RNNs</a:t>
+                        <a:t>Disaster location descriptions go beyond place names and are hard for typical NER tools</a:t>
                       </a:r>
                       <a:endParaRPr sz="1800" u="none" strike="noStrike" cap="none" dirty="0"/>
                     </a:p>
@@ -23942,13 +23208,13 @@
                         <a:buChar char="•"/>
                       </a:pPr>
                       <a:r>
-                        <a:rPr sz="1000" b="0">
+                        <a:rPr sz="1300" b="0">
                           <a:solidFill>
                             <a:srgbClr val="000000"/>
                           </a:solidFill>
                           <a:latin typeface="Calibri"/>
                         </a:rPr>
-                        <a:t>Faster detection of complex flood patterns</a:t>
+                        <a:t>Fuses geo-knowledge with GPT models using only 22 training examples</a:t>
                       </a:r>
                     </a:p>
                     <a:p>
@@ -23957,13 +23223,13 @@
                         <a:buChar char="•"/>
                       </a:pPr>
                       <a:r>
-                        <a:rPr sz="1000" b="0">
+                        <a:rPr sz="1300" b="0">
                           <a:solidFill>
                             <a:srgbClr val="000000"/>
                           </a:solidFill>
                           <a:latin typeface="Calibri"/>
                         </a:rPr>
-                        <a:t>Poor performance in new regions without retraining</a:t>
+                        <a:t>Over 40% improvement over NER approaches on Hurricane Harvey tweets</a:t>
                       </a:r>
                     </a:p>
                     <a:p>
@@ -23972,13 +23238,13 @@
                         <a:buChar char="•"/>
                       </a:pPr>
                       <a:r>
-                        <a:rPr sz="1000" b="0">
+                        <a:rPr sz="1300" b="0">
                           <a:solidFill>
                             <a:srgbClr val="000000"/>
                           </a:solidFill>
                           <a:latin typeface="Calibri"/>
                         </a:rPr>
-                        <a:t>Transfer learning suggested for global use</a:t>
+                        <a:t>Geo-knowledge is indispensable for guiding GPT behaviour</a:t>
                       </a:r>
                     </a:p>
                   </a:txBody>
@@ -23987,442 +23253,6 @@
                 <a:extLst>
                   <a:ext uri="{0D108BD9-81ED-4DB2-BD59-A6C34878D82A}">
                     <a16:rowId xmlns:a16="http://schemas.microsoft.com/office/drawing/2014/main" val="10001"/>
-                  </a:ext>
-                </a:extLst>
-              </a:tr>
-              <a:tr h="1318300">
-                <a:tc>
-                  <a:txBody>
-                    <a:bodyPr/>
-                    <a:lstStyle/>
-                    <a:p>
-                      <a:pPr marL="0" marR="0" lvl="0" indent="0" algn="l" rtl="0">
-                        <a:lnSpc>
-                          <a:spcPct val="100000"/>
-                        </a:lnSpc>
-                        <a:spcBef>
-                          <a:spcPts val="0"/>
-                        </a:spcBef>
-                        <a:spcAft>
-                          <a:spcPts val="0"/>
-                        </a:spcAft>
-                        <a:buClr>
-                          <a:srgbClr val="000000"/>
-                        </a:buClr>
-                        <a:buSzPts val="1800"/>
-                        <a:buFont typeface="Arial"/>
-                        <a:buNone/>
-                      </a:pPr>
-                      <a:r>
-                        <a:rPr sz="1100" b="0">
-                          <a:solidFill>
-                            <a:srgbClr val="000000"/>
-                          </a:solidFill>
-                          <a:latin typeface="Calibri"/>
-                        </a:rPr>
-                        <a:t>2.</a:t>
-                      </a:r>
-                      <a:endParaRPr sz="1800"/>
-                    </a:p>
-                  </a:txBody>
-                  <a:tcPr marL="91450" marR="91450" marT="45725" marB="45725"/>
-                </a:tc>
-                <a:tc>
-                  <a:txBody>
-                    <a:bodyPr/>
-                    <a:lstStyle/>
-                    <a:p>
-                      <a:pPr marL="0" marR="0" lvl="0" indent="0" algn="l" rtl="0">
-                        <a:lnSpc>
-                          <a:spcPct val="100000"/>
-                        </a:lnSpc>
-                        <a:spcBef>
-                          <a:spcPts val="0"/>
-                        </a:spcBef>
-                        <a:spcAft>
-                          <a:spcPts val="0"/>
-                        </a:spcAft>
-                        <a:buClr>
-                          <a:srgbClr val="000000"/>
-                        </a:buClr>
-                        <a:buSzPts val="1800"/>
-                        <a:buFont typeface="Arial"/>
-                        <a:buNone/>
-                      </a:pPr>
-                      <a:r>
-                        <a:rPr sz="1000" b="0">
-                          <a:solidFill>
-                            <a:srgbClr val="000000"/>
-                          </a:solidFill>
-                          <a:latin typeface="Calibri"/>
-                        </a:rPr>
-                        <a:t>Machine Learning for Disaster Prediction and Preparedness</a:t>
-                      </a:r>
-                      <a:endParaRPr sz="1800"/>
-                    </a:p>
-                    <a:p>
-                      <a:r>
-                        <a:rPr sz="1000" b="0">
-                          <a:solidFill>
-                            <a:srgbClr val="000000"/>
-                          </a:solidFill>
-                          <a:latin typeface="Calibri"/>
-                        </a:rPr>
-                        <a:t>https://www.frontiersin.org/journals/environmental-science/articles/10.3389/fenvs.2023.1194918/full</a:t>
-                      </a:r>
-                    </a:p>
-                  </a:txBody>
-                  <a:tcPr marL="91450" marR="91450" marT="45725" marB="45725"/>
-                </a:tc>
-                <a:tc>
-                  <a:txBody>
-                    <a:bodyPr/>
-                    <a:lstStyle/>
-                    <a:p>
-                      <a:pPr marL="0" marR="0" lvl="0" indent="0" algn="l" rtl="0">
-                        <a:lnSpc>
-                          <a:spcPct val="100000"/>
-                        </a:lnSpc>
-                        <a:spcBef>
-                          <a:spcPts val="0"/>
-                        </a:spcBef>
-                        <a:spcAft>
-                          <a:spcPts val="0"/>
-                        </a:spcAft>
-                        <a:buClr>
-                          <a:srgbClr val="000000"/>
-                        </a:buClr>
-                        <a:buSzPts val="1800"/>
-                        <a:buFont typeface="Arial"/>
-                        <a:buNone/>
-                      </a:pPr>
-                      <a:r>
-                        <a:rPr sz="1000" b="0">
-                          <a:solidFill>
-                            <a:srgbClr val="000000"/>
-                          </a:solidFill>
-                          <a:latin typeface="Calibri"/>
-                        </a:rPr>
-                        <a:t>2 Nov 2023</a:t>
-                      </a:r>
-                      <a:endParaRPr sz="1800" u="none" strike="noStrike" cap="none"/>
-                    </a:p>
-                    <a:p>
-                      <a:r>
-                        <a:rPr sz="1000" b="0">
-                          <a:solidFill>
-                            <a:srgbClr val="000000"/>
-                          </a:solidFill>
-                          <a:latin typeface="Calibri"/>
-                        </a:rPr>
-                        <a:t>Frontiers in Environmental Science</a:t>
-                      </a:r>
-                    </a:p>
-                  </a:txBody>
-                  <a:tcPr marL="91450" marR="91450" marT="45725" marB="45725"/>
-                </a:tc>
-                <a:tc>
-                  <a:txBody>
-                    <a:bodyPr/>
-                    <a:lstStyle/>
-                    <a:p>
-                      <a:pPr marL="114300" marR="0" lvl="0" indent="-114300" algn="l" rtl="0">
-                        <a:lnSpc>
-                          <a:spcPct val="100000"/>
-                        </a:lnSpc>
-                        <a:spcBef>
-                          <a:spcPts val="0"/>
-                        </a:spcBef>
-                        <a:spcAft>
-                          <a:spcPts val="0"/>
-                        </a:spcAft>
-                        <a:buClr>
-                          <a:srgbClr val="000000"/>
-                        </a:buClr>
-                        <a:buSzPts val="1800"/>
-                        <a:buFont typeface="Arial"/>
-                        <a:buChar char="•"/>
-                      </a:pPr>
-                      <a:r>
-                        <a:rPr sz="1000" b="0">
-                          <a:solidFill>
-                            <a:srgbClr val="000000"/>
-                          </a:solidFill>
-                          <a:latin typeface="Calibri"/>
-                        </a:rPr>
-                        <a:t>Evaluated ML models for weather and flood prediction</a:t>
-                      </a:r>
-                      <a:endParaRPr sz="1800" u="none" strike="noStrike" cap="none"/>
-                    </a:p>
-                    <a:p>
-                      <a:pPr marL="114300" indent="-114300">
-                        <a:buFont typeface="Arial"/>
-                        <a:buChar char="•"/>
-                      </a:pPr>
-                      <a:r>
-                        <a:rPr sz="1000" b="0">
-                          <a:solidFill>
-                            <a:srgbClr val="000000"/>
-                          </a:solidFill>
-                          <a:latin typeface="Calibri"/>
-                        </a:rPr>
-                        <a:t>ML detects complex patterns in climate data</a:t>
-                      </a:r>
-                    </a:p>
-                    <a:p>
-                      <a:pPr marL="114300" indent="-114300">
-                        <a:buFont typeface="Arial"/>
-                        <a:buChar char="•"/>
-                      </a:pPr>
-                      <a:r>
-                        <a:rPr sz="1000" b="0">
-                          <a:solidFill>
-                            <a:srgbClr val="000000"/>
-                          </a:solidFill>
-                          <a:latin typeface="Calibri"/>
-                        </a:rPr>
-                        <a:t>Enables faster disaster early warnings</a:t>
-                      </a:r>
-                    </a:p>
-                    <a:p>
-                      <a:pPr marL="114300" indent="-114300">
-                        <a:buFont typeface="Arial"/>
-                        <a:buChar char="•"/>
-                      </a:pPr>
-                      <a:r>
-                        <a:rPr sz="1000" b="0">
-                          <a:solidFill>
-                            <a:srgbClr val="000000"/>
-                          </a:solidFill>
-                          <a:latin typeface="Calibri"/>
-                        </a:rPr>
-                        <a:t>Supports scalable real-time alerts</a:t>
-                      </a:r>
-                    </a:p>
-                  </a:txBody>
-                  <a:tcPr marL="91450" marR="91450" marT="45725" marB="45725"/>
-                </a:tc>
-                <a:extLst>
-                  <a:ext uri="{0D108BD9-81ED-4DB2-BD59-A6C34878D82A}">
-                    <a16:rowId xmlns:a16="http://schemas.microsoft.com/office/drawing/2014/main" val="10002"/>
-                  </a:ext>
-                </a:extLst>
-              </a:tr>
-              <a:tr h="859050">
-                <a:tc>
-                  <a:txBody>
-                    <a:bodyPr/>
-                    <a:lstStyle/>
-                    <a:p>
-                      <a:pPr marL="0" marR="0" lvl="0" indent="0" algn="l" rtl="0">
-                        <a:lnSpc>
-                          <a:spcPct val="100000"/>
-                        </a:lnSpc>
-                        <a:spcBef>
-                          <a:spcPts val="0"/>
-                        </a:spcBef>
-                        <a:spcAft>
-                          <a:spcPts val="0"/>
-                        </a:spcAft>
-                        <a:buClr>
-                          <a:srgbClr val="000000"/>
-                        </a:buClr>
-                        <a:buSzPts val="1800"/>
-                        <a:buFont typeface="Arial"/>
-                        <a:buNone/>
-                      </a:pPr>
-                      <a:r>
-                        <a:rPr sz="1100" b="0">
-                          <a:solidFill>
-                            <a:srgbClr val="000000"/>
-                          </a:solidFill>
-                          <a:latin typeface="Calibri"/>
-                        </a:rPr>
-                        <a:t>3.</a:t>
-                      </a:r>
-                      <a:endParaRPr sz="1800" u="none" strike="noStrike" cap="none"/>
-                    </a:p>
-                  </a:txBody>
-                  <a:tcPr marL="91450" marR="91450" marT="45725" marB="45725"/>
-                </a:tc>
-                <a:tc>
-                  <a:txBody>
-                    <a:bodyPr/>
-                    <a:lstStyle/>
-                    <a:p>
-                      <a:pPr marL="0" marR="0" lvl="0" indent="0" algn="l" rtl="0">
-                        <a:lnSpc>
-                          <a:spcPct val="100000"/>
-                        </a:lnSpc>
-                        <a:spcBef>
-                          <a:spcPts val="0"/>
-                        </a:spcBef>
-                        <a:spcAft>
-                          <a:spcPts val="0"/>
-                        </a:spcAft>
-                        <a:buClr>
-                          <a:srgbClr val="000000"/>
-                        </a:buClr>
-                        <a:buSzPts val="1800"/>
-                        <a:buFont typeface="Arial"/>
-                        <a:buNone/>
-                      </a:pPr>
-                      <a:r>
-                        <a:rPr sz="1000" b="0">
-                          <a:solidFill>
-                            <a:srgbClr val="000000"/>
-                          </a:solidFill>
-                          <a:latin typeface="Calibri"/>
-                        </a:rPr>
-                        <a:t>Comparison of Deep Learning Techniques for River Streamflow Forecasting</a:t>
-                      </a:r>
-                      <a:endParaRPr sz="1800"/>
-                    </a:p>
-                    <a:p>
-                      <a:r>
-                        <a:rPr sz="1000" b="0">
-                          <a:solidFill>
-                            <a:srgbClr val="000000"/>
-                          </a:solidFill>
-                          <a:latin typeface="Calibri"/>
-                        </a:rPr>
-                        <a:t>https://ieeexplore.ieee.org/document/9423961</a:t>
-                      </a:r>
-                    </a:p>
-                  </a:txBody>
-                  <a:tcPr marL="91450" marR="91450" marT="45725" marB="45725"/>
-                </a:tc>
-                <a:tc>
-                  <a:txBody>
-                    <a:bodyPr/>
-                    <a:lstStyle/>
-                    <a:p>
-                      <a:pPr marL="0" marR="0" lvl="0" indent="0" algn="l" rtl="0">
-                        <a:lnSpc>
-                          <a:spcPct val="100000"/>
-                        </a:lnSpc>
-                        <a:spcBef>
-                          <a:spcPts val="0"/>
-                        </a:spcBef>
-                        <a:spcAft>
-                          <a:spcPts val="0"/>
-                        </a:spcAft>
-                        <a:buClr>
-                          <a:srgbClr val="000000"/>
-                        </a:buClr>
-                        <a:buSzPts val="1800"/>
-                        <a:buFont typeface="Arial"/>
-                        <a:buNone/>
-                      </a:pPr>
-                      <a:r>
-                        <a:rPr sz="1000" b="0">
-                          <a:solidFill>
-                            <a:srgbClr val="000000"/>
-                          </a:solidFill>
-                          <a:latin typeface="Calibri"/>
-                        </a:rPr>
-                        <a:t>5 May 2021</a:t>
-                      </a:r>
-                      <a:endParaRPr sz="1800" u="none" strike="noStrike" cap="none" dirty="0"/>
-                    </a:p>
-                    <a:p>
-                      <a:r>
-                        <a:rPr sz="1000" b="0">
-                          <a:solidFill>
-                            <a:srgbClr val="000000"/>
-                          </a:solidFill>
-                          <a:latin typeface="Calibri"/>
-                        </a:rPr>
-                        <a:t>IEEE Access, Vol. 9</a:t>
-                      </a:r>
-                    </a:p>
-                  </a:txBody>
-                  <a:tcPr marL="91450" marR="91450" marT="45725" marB="45725"/>
-                </a:tc>
-                <a:tc>
-                  <a:txBody>
-                    <a:bodyPr/>
-                    <a:lstStyle/>
-                    <a:p>
-                      <a:pPr marL="114300" marR="0" lvl="0" indent="-114300" algn="l" rtl="0">
-                        <a:lnSpc>
-                          <a:spcPct val="100000"/>
-                        </a:lnSpc>
-                        <a:spcBef>
-                          <a:spcPts val="0"/>
-                        </a:spcBef>
-                        <a:spcAft>
-                          <a:spcPts val="0"/>
-                        </a:spcAft>
-                        <a:buClr>
-                          <a:srgbClr val="000000"/>
-                        </a:buClr>
-                        <a:buSzPts val="1800"/>
-                        <a:buFont typeface="Arial"/>
-                        <a:buChar char="•"/>
-                      </a:pPr>
-                      <a:r>
-                        <a:rPr sz="1000" b="0">
-                          <a:solidFill>
-                            <a:srgbClr val="000000"/>
-                          </a:solidFill>
-                          <a:latin typeface="Calibri"/>
-                        </a:rPr>
-                        <a:t>Compared six deep learning models</a:t>
-                      </a:r>
-                      <a:endParaRPr sz="1800" dirty="0"/>
-                    </a:p>
-                    <a:p>
-                      <a:pPr marL="114300" indent="-114300">
-                        <a:buFont typeface="Arial"/>
-                        <a:buChar char="•"/>
-                      </a:pPr>
-                      <a:r>
-                        <a:rPr sz="1000" b="0">
-                          <a:solidFill>
-                            <a:srgbClr val="000000"/>
-                          </a:solidFill>
-                          <a:latin typeface="Calibri"/>
-                        </a:rPr>
-                        <a:t>Daily discharge from seven Red River basin stations</a:t>
-                      </a:r>
-                    </a:p>
-                    <a:p>
-                      <a:pPr marL="114300" indent="-114300">
-                        <a:buFont typeface="Arial"/>
-                        <a:buChar char="•"/>
-                      </a:pPr>
-                      <a:r>
-                        <a:rPr sz="1000" b="0">
-                          <a:solidFill>
-                            <a:srgbClr val="000000"/>
-                          </a:solidFill>
-                          <a:latin typeface="Calibri"/>
-                        </a:rPr>
-                        <a:t>LSTM and GRU outperformed feed-forward and CNN</a:t>
-                      </a:r>
-                    </a:p>
-                    <a:p>
-                      <a:pPr marL="114300" indent="-114300">
-                        <a:buFont typeface="Arial"/>
-                        <a:buChar char="•"/>
-                      </a:pPr>
-                      <a:r>
-                        <a:rPr sz="1000" b="0">
-                          <a:solidFill>
-                            <a:srgbClr val="000000"/>
-                          </a:solidFill>
-                          <a:latin typeface="Calibri"/>
-                        </a:rPr>
-                        <a:t>Single-layer RNNs matched accuracy at lower cost</a:t>
-                      </a:r>
-                    </a:p>
-                  </a:txBody>
-                  <a:tcPr marL="91450" marR="91450" marT="45725" marB="45725"/>
-                </a:tc>
-                <a:extLst>
-                  <a:ext uri="{0D108BD9-81ED-4DB2-BD59-A6C34878D82A}">
-                    <a16:rowId xmlns:a16="http://schemas.microsoft.com/office/drawing/2014/main" val="10003"/>
                   </a:ext>
                 </a:extLst>
               </a:tr>
@@ -24613,6 +23443,75 @@
           </a:prstGeom>
         </p:spPr>
       </p:pic>
+      <p:sp>
+        <p:nvSpPr>
+          <p:cNvPr id="156" name="Rectangle 155"/>
+          <p:cNvSpPr/>
+          <p:nvPr/>
+        </p:nvSpPr>
+        <p:spPr>
+          <a:xfrm>
+            <a:off x="317999" y="5900000"/>
+            <a:ext cx="8454939" cy="560000"/>
+          </a:xfrm>
+          <a:prstGeom prst="rect">
+            <a:avLst/>
+          </a:prstGeom>
+          <a:solidFill>
+            <a:srgbClr val="EFCCBF"/>
+          </a:solidFill>
+          <a:ln>
+            <a:solidFill>
+              <a:srgbClr val="DD8047"/>
+            </a:solidFill>
+          </a:ln>
+          <a:effectLst/>
+        </p:spPr>
+        <p:style>
+          <a:lnRef idx="1">
+            <a:schemeClr val="accent1"/>
+          </a:lnRef>
+          <a:fillRef idx="3">
+            <a:schemeClr val="accent1"/>
+          </a:fillRef>
+          <a:effectRef idx="2">
+            <a:schemeClr val="accent1"/>
+          </a:effectRef>
+          <a:fontRef idx="minor">
+            <a:schemeClr val="lt1"/>
+          </a:fontRef>
+        </p:style>
+        <p:txBody>
+          <a:bodyPr rtlCol="0" anchor="ctr" wrap="square"/>
+          <a:lstStyle/>
+          <a:p>
+            <a:pPr algn="ctr" marL="0" indent="0">
+              <a:spcAft>
+                <a:spcPts val="0"/>
+              </a:spcAft>
+              <a:buNone/>
+            </a:pPr>
+            <a:r>
+              <a:rPr sz="1400" b="1">
+                <a:solidFill>
+                  <a:srgbClr val="000000"/>
+                </a:solidFill>
+                <a:latin typeface="Calibri"/>
+              </a:rPr>
+              <a:t>Use in AwaazSetu (M3 – Location):</a:t>
+            </a:r>
+            <a:r>
+              <a:rPr sz="1400" b="0">
+                <a:solidFill>
+                  <a:srgbClr val="000000"/>
+                </a:solidFill>
+                <a:latin typeface="Calibri"/>
+              </a:rPr>
+              <a:t> an India-specific few-shot extraction prompt combined with the Pune gazetteer of 450 places.</a:t>
+            </a:r>
+          </a:p>
+        </p:txBody>
+      </p:sp>
     </p:spTree>
   </p:cSld>
   <p:clrMapOvr>
@@ -24687,7 +23586,7 @@
                 <a:cs typeface="Rockwell"/>
                 <a:sym typeface="Rockwell"/>
               </a:rPr>
-              <a:t>Literature Survey &amp; Findings : (Survey 4 of 4)</a:t>
+              <a:t>Literature Survey &amp; Findings : (Paper 4 of 4)</a:t>
             </a:r>
             <a:endParaRPr sz="2000" b="1" dirty="0">
               <a:solidFill>
@@ -24965,7 +23864,7 @@
                   </a:ext>
                 </a:extLst>
               </a:tr>
-              <a:tr h="1038050">
+              <a:tr h="2700000">
                 <a:tc>
                   <a:txBody>
                     <a:bodyPr/>
@@ -24989,13 +23888,13 @@
                         <a:buNone/>
                       </a:pPr>
                       <a:r>
-                        <a:rPr sz="1100" b="0">
+                        <a:rPr sz="1400" b="0">
                           <a:solidFill>
                             <a:srgbClr val="000000"/>
                           </a:solidFill>
                           <a:latin typeface="Calibri"/>
                         </a:rPr>
-                        <a:t>1.</a:t>
+                        <a:t>4.</a:t>
                       </a:r>
                       <a:endParaRPr sz="1600" dirty="0"/>
                     </a:p>
@@ -25025,25 +23924,25 @@
                         <a:buNone/>
                       </a:pPr>
                       <a:r>
-                        <a:rPr sz="1000" b="0">
+                        <a:rPr sz="1300" b="0">
                           <a:solidFill>
                             <a:srgbClr val="000000"/>
                           </a:solidFill>
                           <a:latin typeface="Calibri"/>
                         </a:rPr>
-                        <a:t>A systematic review of social media-enabled flood disaster informatics: method, technology and application</a:t>
+                        <a:t>Wang et al., 2025 — Mining socioenvironmental drivers of bias in social media rescue data for fairness-aware modeling: A case study of Hurricane Harvey</a:t>
                       </a:r>
                       <a:endParaRPr sz="1800" u="none" strike="noStrike" cap="none"/>
                     </a:p>
                     <a:p>
                       <a:r>
-                        <a:rPr sz="1000" b="0">
+                        <a:rPr sz="1300" b="0">
                           <a:solidFill>
                             <a:srgbClr val="000000"/>
                           </a:solidFill>
                           <a:latin typeface="Calibri"/>
                         </a:rPr>
-                        <a:t>https://doi.org/10.1016/j.jag.2025.104935</a:t>
+                        <a:t>https://doi.org/10.1016/j.ijdrr.2025.105717</a:t>
                       </a:r>
                     </a:p>
                   </a:txBody>
@@ -25072,25 +23971,36 @@
                         <a:buNone/>
                       </a:pPr>
                       <a:r>
-                        <a:rPr sz="1000" b="0">
+                        <a:rPr sz="1300" b="0">
                           <a:solidFill>
                             <a:srgbClr val="000000"/>
                           </a:solidFill>
                           <a:latin typeface="Calibri"/>
                         </a:rPr>
-                        <a:t>2025</a:t>
+                        <a:t>Year: 2025</a:t>
                       </a:r>
                       <a:endParaRPr sz="1800" u="none" strike="noStrike" cap="none"/>
                     </a:p>
                     <a:p>
                       <a:r>
-                        <a:rPr sz="1000" b="0">
+                        <a:rPr sz="1300" b="0">
                           <a:solidFill>
                             <a:srgbClr val="000000"/>
                           </a:solidFill>
                           <a:latin typeface="Calibri"/>
                         </a:rPr>
-                        <a:t>Int. J. of Applied Earth Observation and Geoinformation (Elsevier)</a:t>
+                        <a:t>International Journal of Disaster Risk Reduction, Vol. 128 (Elsevier)</a:t>
+                      </a:r>
+                    </a:p>
+                    <a:p>
+                      <a:r>
+                        <a:rPr sz="1300" b="0">
+                          <a:solidFill>
+                            <a:srgbClr val="000000"/>
+                          </a:solidFill>
+                          <a:latin typeface="Calibri"/>
+                        </a:rPr>
+                        <a:t>Research paper</a:t>
                       </a:r>
                     </a:p>
                   </a:txBody>
@@ -25119,13 +24029,13 @@
                         <a:buChar char="•"/>
                       </a:pPr>
                       <a:r>
-                        <a:rPr sz="1000" b="0">
+                        <a:rPr sz="1300" b="0">
                           <a:solidFill>
                             <a:srgbClr val="000000"/>
                           </a:solidFill>
                           <a:latin typeface="Calibri"/>
                         </a:rPr>
-                        <a:t>Social media fills gaps in traditional monitoring</a:t>
+                        <a:t>Social media users do not represent the whole population, biasing rescue models</a:t>
                       </a:r>
                       <a:endParaRPr sz="1800" u="none" strike="noStrike" cap="none" dirty="0"/>
                     </a:p>
@@ -25135,13 +24045,13 @@
                         <a:buChar char="•"/>
                       </a:pPr>
                       <a:r>
-                        <a:rPr sz="1000" b="0">
+                        <a:rPr sz="1300" b="0">
                           <a:solidFill>
                             <a:srgbClr val="000000"/>
                           </a:solidFill>
                           <a:latin typeface="Calibri"/>
                         </a:rPr>
-                        <a:t>Multimodal data + AI boosts flood monitoring</a:t>
+                        <a:t>Defines Expected Rescue Requests and a Rescue Request Difference (RRD) index</a:t>
                       </a:r>
                     </a:p>
                     <a:p>
@@ -25150,13 +24060,13 @@
                         <a:buChar char="•"/>
                       </a:pPr>
                       <a:r>
-                        <a:rPr sz="1000" b="0">
+                        <a:rPr sz="1300" b="0">
                           <a:solidFill>
                             <a:srgbClr val="000000"/>
                           </a:solidFill>
                           <a:latin typeface="Calibri"/>
                         </a:rPr>
-                        <a:t>Authenticity checks and integration remain open</a:t>
+                        <a:t>35 geographic, socioeconomic and digital-access variables; 1,807 requests, 534 block groups</a:t>
                       </a:r>
                     </a:p>
                     <a:p>
@@ -25165,13 +24075,13 @@
                         <a:buChar char="•"/>
                       </a:pPr>
                       <a:r>
-                        <a:rPr sz="1000" b="0">
+                        <a:rPr sz="1300" b="0">
                           <a:solidFill>
                             <a:srgbClr val="000000"/>
                           </a:solidFill>
                           <a:latin typeface="Calibri"/>
                         </a:rPr>
-                        <a:t>Pipeline: analysis → detection → awareness → mapping → response</a:t>
+                        <a:t>% Minority and road density identified as sensitive attributes for fairness</a:t>
                       </a:r>
                     </a:p>
                   </a:txBody>
@@ -25180,442 +24090,6 @@
                 <a:extLst>
                   <a:ext uri="{0D108BD9-81ED-4DB2-BD59-A6C34878D82A}">
                     <a16:rowId xmlns:a16="http://schemas.microsoft.com/office/drawing/2014/main" val="10001"/>
-                  </a:ext>
-                </a:extLst>
-              </a:tr>
-              <a:tr h="1318300">
-                <a:tc>
-                  <a:txBody>
-                    <a:bodyPr/>
-                    <a:lstStyle/>
-                    <a:p>
-                      <a:pPr marL="0" marR="0" lvl="0" indent="0" algn="l" rtl="0">
-                        <a:lnSpc>
-                          <a:spcPct val="100000"/>
-                        </a:lnSpc>
-                        <a:spcBef>
-                          <a:spcPts val="0"/>
-                        </a:spcBef>
-                        <a:spcAft>
-                          <a:spcPts val="0"/>
-                        </a:spcAft>
-                        <a:buClr>
-                          <a:srgbClr val="000000"/>
-                        </a:buClr>
-                        <a:buSzPts val="1800"/>
-                        <a:buFont typeface="Arial"/>
-                        <a:buNone/>
-                      </a:pPr>
-                      <a:r>
-                        <a:rPr sz="1100" b="0">
-                          <a:solidFill>
-                            <a:srgbClr val="000000"/>
-                          </a:solidFill>
-                          <a:latin typeface="Calibri"/>
-                        </a:rPr>
-                        <a:t>2.</a:t>
-                      </a:r>
-                      <a:endParaRPr sz="1800"/>
-                    </a:p>
-                  </a:txBody>
-                  <a:tcPr marL="91450" marR="91450" marT="45725" marB="45725"/>
-                </a:tc>
-                <a:tc>
-                  <a:txBody>
-                    <a:bodyPr/>
-                    <a:lstStyle/>
-                    <a:p>
-                      <a:pPr marL="0" marR="0" lvl="0" indent="0" algn="l" rtl="0">
-                        <a:lnSpc>
-                          <a:spcPct val="100000"/>
-                        </a:lnSpc>
-                        <a:spcBef>
-                          <a:spcPts val="0"/>
-                        </a:spcBef>
-                        <a:spcAft>
-                          <a:spcPts val="0"/>
-                        </a:spcAft>
-                        <a:buClr>
-                          <a:srgbClr val="000000"/>
-                        </a:buClr>
-                        <a:buSzPts val="1800"/>
-                        <a:buFont typeface="Arial"/>
-                        <a:buNone/>
-                      </a:pPr>
-                      <a:r>
-                        <a:rPr sz="1000" b="0">
-                          <a:solidFill>
-                            <a:srgbClr val="000000"/>
-                          </a:solidFill>
-                          <a:latin typeface="Calibri"/>
-                        </a:rPr>
-                        <a:t>Prototype citizen and community science app for urban heavy rainfall risk management in the Ahr Valley, Germany</a:t>
-                      </a:r>
-                      <a:endParaRPr sz="1800"/>
-                    </a:p>
-                    <a:p>
-                      <a:r>
-                        <a:rPr sz="1000" b="0">
-                          <a:solidFill>
-                            <a:srgbClr val="000000"/>
-                          </a:solidFill>
-                          <a:latin typeface="Calibri"/>
-                        </a:rPr>
-                        <a:t>https://doi.org/10.5194/nhess-26-1795-2026</a:t>
-                      </a:r>
-                    </a:p>
-                  </a:txBody>
-                  <a:tcPr marL="91450" marR="91450" marT="45725" marB="45725"/>
-                </a:tc>
-                <a:tc>
-                  <a:txBody>
-                    <a:bodyPr/>
-                    <a:lstStyle/>
-                    <a:p>
-                      <a:pPr marL="0" marR="0" lvl="0" indent="0" algn="l" rtl="0">
-                        <a:lnSpc>
-                          <a:spcPct val="100000"/>
-                        </a:lnSpc>
-                        <a:spcBef>
-                          <a:spcPts val="0"/>
-                        </a:spcBef>
-                        <a:spcAft>
-                          <a:spcPts val="0"/>
-                        </a:spcAft>
-                        <a:buClr>
-                          <a:srgbClr val="000000"/>
-                        </a:buClr>
-                        <a:buSzPts val="1800"/>
-                        <a:buFont typeface="Arial"/>
-                        <a:buNone/>
-                      </a:pPr>
-                      <a:r>
-                        <a:rPr sz="1000" b="0">
-                          <a:solidFill>
-                            <a:srgbClr val="000000"/>
-                          </a:solidFill>
-                          <a:latin typeface="Calibri"/>
-                        </a:rPr>
-                        <a:t>2026</a:t>
-                      </a:r>
-                      <a:endParaRPr sz="1800" u="none" strike="noStrike" cap="none"/>
-                    </a:p>
-                    <a:p>
-                      <a:r>
-                        <a:rPr sz="1000" b="0">
-                          <a:solidFill>
-                            <a:srgbClr val="000000"/>
-                          </a:solidFill>
-                          <a:latin typeface="Calibri"/>
-                        </a:rPr>
-                        <a:t>Natural Hazards and Earth System Sciences (Copernicus)</a:t>
-                      </a:r>
-                    </a:p>
-                  </a:txBody>
-                  <a:tcPr marL="91450" marR="91450" marT="45725" marB="45725"/>
-                </a:tc>
-                <a:tc>
-                  <a:txBody>
-                    <a:bodyPr/>
-                    <a:lstStyle/>
-                    <a:p>
-                      <a:pPr marL="114300" marR="0" lvl="0" indent="-114300" algn="l" rtl="0">
-                        <a:lnSpc>
-                          <a:spcPct val="100000"/>
-                        </a:lnSpc>
-                        <a:spcBef>
-                          <a:spcPts val="0"/>
-                        </a:spcBef>
-                        <a:spcAft>
-                          <a:spcPts val="0"/>
-                        </a:spcAft>
-                        <a:buClr>
-                          <a:srgbClr val="000000"/>
-                        </a:buClr>
-                        <a:buSzPts val="1800"/>
-                        <a:buFont typeface="Arial"/>
-                        <a:buChar char="•"/>
-                      </a:pPr>
-                      <a:r>
-                        <a:rPr sz="1000" b="0">
-                          <a:solidFill>
-                            <a:srgbClr val="000000"/>
-                          </a:solidFill>
-                          <a:latin typeface="Calibri"/>
-                        </a:rPr>
-                        <a:t>Personal risk perception drives action</a:t>
-                      </a:r>
-                      <a:endParaRPr sz="1800" u="none" strike="noStrike" cap="none"/>
-                    </a:p>
-                    <a:p>
-                      <a:pPr marL="114300" indent="-114300">
-                        <a:buFont typeface="Arial"/>
-                        <a:buChar char="•"/>
-                      </a:pPr>
-                      <a:r>
-                        <a:rPr sz="1000" b="0">
-                          <a:solidFill>
-                            <a:srgbClr val="000000"/>
-                          </a:solidFill>
-                          <a:latin typeface="Calibri"/>
-                        </a:rPr>
-                        <a:t>Hybrid app → API → geo data warehouse</a:t>
-                      </a:r>
-                    </a:p>
-                    <a:p>
-                      <a:pPr marL="114300" indent="-114300">
-                        <a:buFont typeface="Arial"/>
-                        <a:buChar char="•"/>
-                      </a:pPr>
-                      <a:r>
-                        <a:rPr sz="1000" b="0">
-                          <a:solidFill>
-                            <a:srgbClr val="000000"/>
-                          </a:solidFill>
-                          <a:latin typeface="Calibri"/>
-                        </a:rPr>
-                        <a:t>Privacy by design with anonymous IDs</a:t>
-                      </a:r>
-                    </a:p>
-                    <a:p>
-                      <a:pPr marL="114300" indent="-114300">
-                        <a:buFont typeface="Arial"/>
-                        <a:buChar char="•"/>
-                      </a:pPr>
-                      <a:r>
-                        <a:rPr sz="1000" b="0">
-                          <a:solidFill>
-                            <a:srgbClr val="000000"/>
-                          </a:solidFill>
-                          <a:latin typeface="Calibri"/>
-                        </a:rPr>
-                        <a:t>Gaps: offline support, GNSS accuracy, validation</a:t>
-                      </a:r>
-                    </a:p>
-                  </a:txBody>
-                  <a:tcPr marL="91450" marR="91450" marT="45725" marB="45725"/>
-                </a:tc>
-                <a:extLst>
-                  <a:ext uri="{0D108BD9-81ED-4DB2-BD59-A6C34878D82A}">
-                    <a16:rowId xmlns:a16="http://schemas.microsoft.com/office/drawing/2014/main" val="10002"/>
-                  </a:ext>
-                </a:extLst>
-              </a:tr>
-              <a:tr h="859050">
-                <a:tc>
-                  <a:txBody>
-                    <a:bodyPr/>
-                    <a:lstStyle/>
-                    <a:p>
-                      <a:pPr marL="0" marR="0" lvl="0" indent="0" algn="l" rtl="0">
-                        <a:lnSpc>
-                          <a:spcPct val="100000"/>
-                        </a:lnSpc>
-                        <a:spcBef>
-                          <a:spcPts val="0"/>
-                        </a:spcBef>
-                        <a:spcAft>
-                          <a:spcPts val="0"/>
-                        </a:spcAft>
-                        <a:buClr>
-                          <a:srgbClr val="000000"/>
-                        </a:buClr>
-                        <a:buSzPts val="1800"/>
-                        <a:buFont typeface="Arial"/>
-                        <a:buNone/>
-                      </a:pPr>
-                      <a:r>
-                        <a:rPr sz="1100" b="0">
-                          <a:solidFill>
-                            <a:srgbClr val="000000"/>
-                          </a:solidFill>
-                          <a:latin typeface="Calibri"/>
-                        </a:rPr>
-                        <a:t>3.</a:t>
-                      </a:r>
-                      <a:endParaRPr sz="1800" u="none" strike="noStrike" cap="none"/>
-                    </a:p>
-                  </a:txBody>
-                  <a:tcPr marL="91450" marR="91450" marT="45725" marB="45725"/>
-                </a:tc>
-                <a:tc>
-                  <a:txBody>
-                    <a:bodyPr/>
-                    <a:lstStyle/>
-                    <a:p>
-                      <a:pPr marL="0" marR="0" lvl="0" indent="0" algn="l" rtl="0">
-                        <a:lnSpc>
-                          <a:spcPct val="100000"/>
-                        </a:lnSpc>
-                        <a:spcBef>
-                          <a:spcPts val="0"/>
-                        </a:spcBef>
-                        <a:spcAft>
-                          <a:spcPts val="0"/>
-                        </a:spcAft>
-                        <a:buClr>
-                          <a:srgbClr val="000000"/>
-                        </a:buClr>
-                        <a:buSzPts val="1800"/>
-                        <a:buFont typeface="Arial"/>
-                        <a:buNone/>
-                      </a:pPr>
-                      <a:r>
-                        <a:rPr sz="1000" b="0">
-                          <a:solidFill>
-                            <a:srgbClr val="000000"/>
-                          </a:solidFill>
-                          <a:latin typeface="Calibri"/>
-                        </a:rPr>
-                        <a:t>Mobile and web-based application for flood data collection based on citizen science</a:t>
-                      </a:r>
-                      <a:endParaRPr sz="1800"/>
-                    </a:p>
-                    <a:p>
-                      <a:r>
-                        <a:rPr sz="1000" b="0">
-                          <a:solidFill>
-                            <a:srgbClr val="000000"/>
-                          </a:solidFill>
-                          <a:latin typeface="Calibri"/>
-                        </a:rPr>
-                        <a:t>doi:10.1007/s12145-024-01664-1</a:t>
-                      </a:r>
-                    </a:p>
-                  </a:txBody>
-                  <a:tcPr marL="91450" marR="91450" marT="45725" marB="45725"/>
-                </a:tc>
-                <a:tc>
-                  <a:txBody>
-                    <a:bodyPr/>
-                    <a:lstStyle/>
-                    <a:p>
-                      <a:pPr marL="0" marR="0" lvl="0" indent="0" algn="l" rtl="0">
-                        <a:lnSpc>
-                          <a:spcPct val="100000"/>
-                        </a:lnSpc>
-                        <a:spcBef>
-                          <a:spcPts val="0"/>
-                        </a:spcBef>
-                        <a:spcAft>
-                          <a:spcPts val="0"/>
-                        </a:spcAft>
-                        <a:buClr>
-                          <a:srgbClr val="000000"/>
-                        </a:buClr>
-                        <a:buSzPts val="1800"/>
-                        <a:buFont typeface="Arial"/>
-                        <a:buNone/>
-                      </a:pPr>
-                      <a:r>
-                        <a:rPr sz="1000" b="0">
-                          <a:solidFill>
-                            <a:srgbClr val="000000"/>
-                          </a:solidFill>
-                          <a:latin typeface="Calibri"/>
-                        </a:rPr>
-                        <a:t>2025</a:t>
-                      </a:r>
-                      <a:endParaRPr sz="1800" u="none" strike="noStrike" cap="none" dirty="0"/>
-                    </a:p>
-                    <a:p>
-                      <a:r>
-                        <a:rPr sz="1000" b="0">
-                          <a:solidFill>
-                            <a:srgbClr val="000000"/>
-                          </a:solidFill>
-                          <a:latin typeface="Calibri"/>
-                        </a:rPr>
-                        <a:t>Earth Science Informatics (Springer)</a:t>
-                      </a:r>
-                    </a:p>
-                  </a:txBody>
-                  <a:tcPr marL="91450" marR="91450" marT="45725" marB="45725"/>
-                </a:tc>
-                <a:tc>
-                  <a:txBody>
-                    <a:bodyPr/>
-                    <a:lstStyle/>
-                    <a:p>
-                      <a:pPr marL="114300" marR="0" lvl="0" indent="-114300" algn="l" rtl="0">
-                        <a:lnSpc>
-                          <a:spcPct val="100000"/>
-                        </a:lnSpc>
-                        <a:spcBef>
-                          <a:spcPts val="0"/>
-                        </a:spcBef>
-                        <a:spcAft>
-                          <a:spcPts val="0"/>
-                        </a:spcAft>
-                        <a:buClr>
-                          <a:srgbClr val="000000"/>
-                        </a:buClr>
-                        <a:buSzPts val="1800"/>
-                        <a:buFont typeface="Arial"/>
-                        <a:buChar char="•"/>
-                      </a:pPr>
-                      <a:r>
-                        <a:rPr sz="1000" b="0">
-                          <a:solidFill>
-                            <a:srgbClr val="000000"/>
-                          </a:solidFill>
-                          <a:latin typeface="Calibri"/>
-                        </a:rPr>
-                        <a:t>Modified Design Thinking suits small teams</a:t>
-                      </a:r>
-                      <a:endParaRPr sz="1800" dirty="0"/>
-                    </a:p>
-                    <a:p>
-                      <a:pPr marL="114300" indent="-114300">
-                        <a:buFont typeface="Arial"/>
-                        <a:buChar char="•"/>
-                      </a:pPr>
-                      <a:r>
-                        <a:rPr sz="1000" b="0">
-                          <a:solidFill>
-                            <a:srgbClr val="000000"/>
-                          </a:solidFill>
-                          <a:latin typeface="Calibri"/>
-                        </a:rPr>
-                        <a:t>App data + social images + satellite estimates</a:t>
-                      </a:r>
-                    </a:p>
-                    <a:p>
-                      <a:pPr marL="114300" indent="-114300">
-                        <a:buFont typeface="Arial"/>
-                        <a:buChar char="•"/>
-                      </a:pPr>
-                      <a:r>
-                        <a:rPr sz="1000" b="0">
-                          <a:solidFill>
-                            <a:srgbClr val="000000"/>
-                          </a:solidFill>
-                          <a:latin typeface="Calibri"/>
-                        </a:rPr>
-                        <a:t>Structured DB enables web-GIS queries</a:t>
-                      </a:r>
-                    </a:p>
-                    <a:p>
-                      <a:pPr marL="114300" indent="-114300">
-                        <a:buFont typeface="Arial"/>
-                        <a:buChar char="•"/>
-                      </a:pPr>
-                      <a:r>
-                        <a:rPr sz="1000" b="0">
-                          <a:solidFill>
-                            <a:srgbClr val="000000"/>
-                          </a:solidFill>
-                          <a:latin typeface="Calibri"/>
-                        </a:rPr>
-                        <a:t>CSV export; 97 users, 212 rows at prototype scale</a:t>
-                      </a:r>
-                    </a:p>
-                  </a:txBody>
-                  <a:tcPr marL="91450" marR="91450" marT="45725" marB="45725"/>
-                </a:tc>
-                <a:extLst>
-                  <a:ext uri="{0D108BD9-81ED-4DB2-BD59-A6C34878D82A}">
-                    <a16:rowId xmlns:a16="http://schemas.microsoft.com/office/drawing/2014/main" val="10003"/>
                   </a:ext>
                 </a:extLst>
               </a:tr>
@@ -25806,6 +24280,75 @@
           </a:prstGeom>
         </p:spPr>
       </p:pic>
+      <p:sp>
+        <p:nvSpPr>
+          <p:cNvPr id="156" name="Rectangle 155"/>
+          <p:cNvSpPr/>
+          <p:nvPr/>
+        </p:nvSpPr>
+        <p:spPr>
+          <a:xfrm>
+            <a:off x="317999" y="5900000"/>
+            <a:ext cx="8454939" cy="560000"/>
+          </a:xfrm>
+          <a:prstGeom prst="rect">
+            <a:avLst/>
+          </a:prstGeom>
+          <a:solidFill>
+            <a:srgbClr val="EFCCBF"/>
+          </a:solidFill>
+          <a:ln>
+            <a:solidFill>
+              <a:srgbClr val="DD8047"/>
+            </a:solidFill>
+          </a:ln>
+          <a:effectLst/>
+        </p:spPr>
+        <p:style>
+          <a:lnRef idx="1">
+            <a:schemeClr val="accent1"/>
+          </a:lnRef>
+          <a:fillRef idx="3">
+            <a:schemeClr val="accent1"/>
+          </a:fillRef>
+          <a:effectRef idx="2">
+            <a:schemeClr val="accent1"/>
+          </a:effectRef>
+          <a:fontRef idx="minor">
+            <a:schemeClr val="lt1"/>
+          </a:fontRef>
+        </p:style>
+        <p:txBody>
+          <a:bodyPr rtlCol="0" anchor="ctr" wrap="square"/>
+          <a:lstStyle/>
+          <a:p>
+            <a:pPr algn="ctr" marL="0" indent="0">
+              <a:spcAft>
+                <a:spcPts val="0"/>
+              </a:spcAft>
+              <a:buNone/>
+            </a:pPr>
+            <a:r>
+              <a:rPr sz="1400" b="1">
+                <a:solidFill>
+                  <a:srgbClr val="000000"/>
+                </a:solidFill>
+                <a:latin typeface="Calibri"/>
+              </a:rPr>
+              <a:t>Use in AwaazSetu (M4 – Coverage):</a:t>
+            </a:r>
+            <a:r>
+              <a:rPr sz="1400" b="0">
+                <a:solidFill>
+                  <a:srgbClr val="000000"/>
+                </a:solidFill>
+                <a:latin typeface="Calibri"/>
+              </a:rPr>
+              <a:t> a coverage gap index per ward comparing observed reports with an expected baseline.</a:t>
+            </a:r>
+          </a:p>
+        </p:txBody>
+      </p:sp>
     </p:spTree>
   </p:cSld>
   <p:clrMapOvr>

</xml_diff>

<commit_message>
Add datasets used to each Review II literature slide
Co-Authored-By: Claude Opus 5.5 <noreply@anthropic.com>
Claude-Session: https://claude.ai/code/session_015D4bQVZNhTGUwEsTWPJArD
</commit_message>
<xml_diff>
--- a/submission/CEP_Review_II_AwaazSetu.pptx
+++ b/submission/CEP_Review_II_AwaazSetu.pptx
@@ -21353,7 +21353,7 @@
                   </a:ext>
                 </a:extLst>
               </a:tr>
-              <a:tr h="2700000">
+              <a:tr h="2250000">
                 <a:tc>
                   <a:txBody>
                     <a:bodyPr/>
@@ -21413,7 +21413,7 @@
                         <a:buNone/>
                       </a:pPr>
                       <a:r>
-                        <a:rPr sz="1300" b="0">
+                        <a:rPr sz="1200" b="0">
                           <a:solidFill>
                             <a:srgbClr val="000000"/>
                           </a:solidFill>
@@ -21425,7 +21425,7 @@
                     </a:p>
                     <a:p>
                       <a:r>
-                        <a:rPr sz="1300" b="0">
+                        <a:rPr sz="1200" b="0">
                           <a:solidFill>
                             <a:srgbClr val="000000"/>
                           </a:solidFill>
@@ -21460,7 +21460,7 @@
                         <a:buNone/>
                       </a:pPr>
                       <a:r>
-                        <a:rPr sz="1300" b="0">
+                        <a:rPr sz="1200" b="0">
                           <a:solidFill>
                             <a:srgbClr val="000000"/>
                           </a:solidFill>
@@ -21472,7 +21472,7 @@
                     </a:p>
                     <a:p>
                       <a:r>
-                        <a:rPr sz="1300" b="0">
+                        <a:rPr sz="1200" b="0">
                           <a:solidFill>
                             <a:srgbClr val="000000"/>
                           </a:solidFill>
@@ -21483,7 +21483,7 @@
                     </a:p>
                     <a:p>
                       <a:r>
-                        <a:rPr sz="1300" b="0">
+                        <a:rPr sz="1200" b="0">
                           <a:solidFill>
                             <a:srgbClr val="000000"/>
                           </a:solidFill>
@@ -21518,7 +21518,7 @@
                         <a:buChar char="•"/>
                       </a:pPr>
                       <a:r>
-                        <a:rPr sz="1300" b="0">
+                        <a:rPr sz="1200" b="0">
                           <a:solidFill>
                             <a:srgbClr val="000000"/>
                           </a:solidFill>
@@ -21534,7 +21534,7 @@
                         <a:buChar char="•"/>
                       </a:pPr>
                       <a:r>
-                        <a:rPr sz="1300" b="0">
+                        <a:rPr sz="1200" b="0">
                           <a:solidFill>
                             <a:srgbClr val="000000"/>
                           </a:solidFill>
@@ -21549,7 +21549,7 @@
                         <a:buChar char="•"/>
                       </a:pPr>
                       <a:r>
-                        <a:rPr sz="1300" b="0">
+                        <a:rPr sz="1200" b="0">
                           <a:solidFill>
                             <a:srgbClr val="000000"/>
                           </a:solidFill>
@@ -21564,7 +21564,7 @@
                         <a:buChar char="•"/>
                       </a:pPr>
                       <a:r>
-                        <a:rPr sz="1300" b="0">
+                        <a:rPr sz="1200" b="0">
                           <a:solidFill>
                             <a:srgbClr val="000000"/>
                           </a:solidFill>
@@ -21777,8 +21777,77 @@
         </p:nvSpPr>
         <p:spPr>
           <a:xfrm>
-            <a:off x="317999" y="5900000"/>
-            <a:ext cx="8454939" cy="560000"/>
+            <a:off x="317999" y="5300000"/>
+            <a:ext cx="8454939" cy="620000"/>
+          </a:xfrm>
+          <a:prstGeom prst="rect">
+            <a:avLst/>
+          </a:prstGeom>
+          <a:solidFill>
+            <a:srgbClr val="EAF1F7"/>
+          </a:solidFill>
+          <a:ln>
+            <a:solidFill>
+              <a:srgbClr val="94B6D2"/>
+            </a:solidFill>
+          </a:ln>
+          <a:effectLst/>
+        </p:spPr>
+        <p:style>
+          <a:lnRef idx="1">
+            <a:schemeClr val="accent1"/>
+          </a:lnRef>
+          <a:fillRef idx="3">
+            <a:schemeClr val="accent1"/>
+          </a:fillRef>
+          <a:effectRef idx="2">
+            <a:schemeClr val="accent1"/>
+          </a:effectRef>
+          <a:fontRef idx="minor">
+            <a:schemeClr val="lt1"/>
+          </a:fontRef>
+        </p:style>
+        <p:txBody>
+          <a:bodyPr rtlCol="0" anchor="ctr" wrap="square"/>
+          <a:lstStyle/>
+          <a:p>
+            <a:pPr algn="l" marL="0" indent="0">
+              <a:spcAft>
+                <a:spcPts val="0"/>
+              </a:spcAft>
+              <a:buNone/>
+            </a:pPr>
+            <a:r>
+              <a:rPr sz="1200" b="1">
+                <a:solidFill>
+                  <a:srgbClr val="000000"/>
+                </a:solidFill>
+                <a:latin typeface="Calibri"/>
+              </a:rPr>
+              <a:t>Dataset(s) used:</a:t>
+            </a:r>
+            <a:r>
+              <a:rPr sz="1200" b="0">
+                <a:solidFill>
+                  <a:srgbClr val="000000"/>
+                </a:solidFill>
+                <a:latin typeface="Calibri"/>
+              </a:rPr>
+              <a:t> IndicVoices corpus — 7,348 h, 22 languages, 16,237 speakers, released by AI4Bharat (huggingface.co/datasets/ai4bharat/IndicVoices · arXiv:2403.01926).</a:t>
+            </a:r>
+          </a:p>
+        </p:txBody>
+      </p:sp>
+      <p:sp>
+        <p:nvSpPr>
+          <p:cNvPr id="157" name="Rectangle 156"/>
+          <p:cNvSpPr/>
+          <p:nvPr/>
+        </p:nvSpPr>
+        <p:spPr>
+          <a:xfrm>
+            <a:off x="317999" y="6020000"/>
+            <a:ext cx="8454939" cy="520000"/>
           </a:xfrm>
           <a:prstGeom prst="rect">
             <a:avLst/>
@@ -21818,7 +21887,7 @@
               <a:buNone/>
             </a:pPr>
             <a:r>
-              <a:rPr sz="1400" b="1">
+              <a:rPr sz="1300" b="1">
                 <a:solidFill>
                   <a:srgbClr val="000000"/>
                 </a:solidFill>
@@ -21827,7 +21896,7 @@
               <a:t>Use in AwaazSetu (M1 – Intake):</a:t>
             </a:r>
             <a:r>
-              <a:rPr sz="1400" b="0">
+              <a:rPr sz="1300" b="0">
                 <a:solidFill>
                   <a:srgbClr val="000000"/>
                 </a:solidFill>
@@ -22190,7 +22259,7 @@
                   </a:ext>
                 </a:extLst>
               </a:tr>
-              <a:tr h="2700000">
+              <a:tr h="2250000">
                 <a:tc>
                   <a:txBody>
                     <a:bodyPr/>
@@ -22250,7 +22319,7 @@
                         <a:buNone/>
                       </a:pPr>
                       <a:r>
-                        <a:rPr sz="1300" b="0">
+                        <a:rPr sz="1200" b="0">
                           <a:solidFill>
                             <a:srgbClr val="000000"/>
                           </a:solidFill>
@@ -22262,7 +22331,7 @@
                     </a:p>
                     <a:p>
                       <a:r>
-                        <a:rPr sz="1300" b="0">
+                        <a:rPr sz="1200" b="0">
                           <a:solidFill>
                             <a:srgbClr val="000000"/>
                           </a:solidFill>
@@ -22297,7 +22366,7 @@
                         <a:buNone/>
                       </a:pPr>
                       <a:r>
-                        <a:rPr sz="1300" b="0">
+                        <a:rPr sz="1200" b="0">
                           <a:solidFill>
                             <a:srgbClr val="000000"/>
                           </a:solidFill>
@@ -22309,7 +22378,7 @@
                     </a:p>
                     <a:p>
                       <a:r>
-                        <a:rPr sz="1300" b="0">
+                        <a:rPr sz="1200" b="0">
                           <a:solidFill>
                             <a:srgbClr val="000000"/>
                           </a:solidFill>
@@ -22320,7 +22389,7 @@
                     </a:p>
                     <a:p>
                       <a:r>
-                        <a:rPr sz="1300" b="0">
+                        <a:rPr sz="1200" b="0">
                           <a:solidFill>
                             <a:srgbClr val="000000"/>
                           </a:solidFill>
@@ -22355,13 +22424,13 @@
                         <a:buChar char="•"/>
                       </a:pPr>
                       <a:r>
-                        <a:rPr sz="1300" b="0">
+                        <a:rPr sz="1200" b="0">
                           <a:solidFill>
                             <a:srgbClr val="000000"/>
                           </a:solidFill>
                           <a:latin typeface="Calibri"/>
                         </a:rPr>
-                        <a:t>Fully automated decisions are inappropriate in high-stakes emergencies; operators stay in control</a:t>
+                        <a:t>Full automation is unsafe in high-stakes emergencies; operators stay in control</a:t>
                       </a:r>
                       <a:endParaRPr sz="1800" u="none" strike="noStrike" cap="none" dirty="0"/>
                     </a:p>
@@ -22371,7 +22440,7 @@
                         <a:buChar char="•"/>
                       </a:pPr>
                       <a:r>
-                        <a:rPr sz="1300" b="0">
+                        <a:rPr sz="1200" b="0">
                           <a:solidFill>
                             <a:srgbClr val="000000"/>
                           </a:solidFill>
@@ -22386,13 +22455,13 @@
                         <a:buChar char="•"/>
                       </a:pPr>
                       <a:r>
-                        <a:rPr sz="1300" b="0">
+                        <a:rPr sz="1200" b="0">
                           <a:solidFill>
                             <a:srgbClr val="000000"/>
                           </a:solidFill>
                           <a:latin typeface="Calibri"/>
                         </a:rPr>
-                        <a:t>Consolidates duplicate incident reports and adds real-time geospatial awareness</a:t>
+                        <a:t>Merges duplicate reports; adds real-time geospatial awareness</a:t>
                       </a:r>
                     </a:p>
                     <a:p>
@@ -22401,13 +22470,13 @@
                         <a:buChar char="•"/>
                       </a:pPr>
                       <a:r>
-                        <a:rPr sz="1300" b="0">
+                        <a:rPr sz="1200" b="0">
                           <a:solidFill>
                             <a:srgbClr val="000000"/>
                           </a:solidFill>
                           <a:latin typeface="Calibri"/>
                         </a:rPr>
-                        <a:t>Synthetic surge evaluation: promising classification with calibrated confidence</a:t>
+                        <a:t>Synthetic surge test: good classification, calibrated confidence</a:t>
                       </a:r>
                     </a:p>
                   </a:txBody>
@@ -22614,8 +22683,77 @@
         </p:nvSpPr>
         <p:spPr>
           <a:xfrm>
-            <a:off x="317999" y="5900000"/>
-            <a:ext cx="8454939" cy="560000"/>
+            <a:off x="317999" y="5300000"/>
+            <a:ext cx="8454939" cy="620000"/>
+          </a:xfrm>
+          <a:prstGeom prst="rect">
+            <a:avLst/>
+          </a:prstGeom>
+          <a:solidFill>
+            <a:srgbClr val="EAF1F7"/>
+          </a:solidFill>
+          <a:ln>
+            <a:solidFill>
+              <a:srgbClr val="94B6D2"/>
+            </a:solidFill>
+          </a:ln>
+          <a:effectLst/>
+        </p:spPr>
+        <p:style>
+          <a:lnRef idx="1">
+            <a:schemeClr val="accent1"/>
+          </a:lnRef>
+          <a:fillRef idx="3">
+            <a:schemeClr val="accent1"/>
+          </a:fillRef>
+          <a:effectRef idx="2">
+            <a:schemeClr val="accent1"/>
+          </a:effectRef>
+          <a:fontRef idx="minor">
+            <a:schemeClr val="lt1"/>
+          </a:fontRef>
+        </p:style>
+        <p:txBody>
+          <a:bodyPr rtlCol="0" anchor="ctr" wrap="square"/>
+          <a:lstStyle/>
+          <a:p>
+            <a:pPr algn="l" marL="0" indent="0">
+              <a:spcAft>
+                <a:spcPts val="0"/>
+              </a:spcAft>
+              <a:buNone/>
+            </a:pPr>
+            <a:r>
+              <a:rPr sz="1200" b="1">
+                <a:solidFill>
+                  <a:srgbClr val="000000"/>
+                </a:solidFill>
+                <a:latin typeface="Calibri"/>
+              </a:rPr>
+              <a:t>Dataset(s) used:</a:t>
+            </a:r>
+            <a:r>
+              <a:rPr sz="1200" b="0">
+                <a:solidFill>
+                  <a:srgbClr val="000000"/>
+                </a:solidFill>
+                <a:latin typeface="Calibri"/>
+              </a:rPr>
+              <a:t> a synthetic, operationally grounded emergency-call dataset built by the authors (call surges, ambiguity, redundant reports); not publicly released.</a:t>
+            </a:r>
+          </a:p>
+        </p:txBody>
+      </p:sp>
+      <p:sp>
+        <p:nvSpPr>
+          <p:cNvPr id="157" name="Rectangle 156"/>
+          <p:cNvSpPr/>
+          <p:nvPr/>
+        </p:nvSpPr>
+        <p:spPr>
+          <a:xfrm>
+            <a:off x="317999" y="6020000"/>
+            <a:ext cx="8454939" cy="520000"/>
           </a:xfrm>
           <a:prstGeom prst="rect">
             <a:avLst/>
@@ -22655,7 +22793,7 @@
               <a:buNone/>
             </a:pPr>
             <a:r>
-              <a:rPr sz="1400" b="1">
+              <a:rPr sz="1300" b="1">
                 <a:solidFill>
                   <a:srgbClr val="000000"/>
                 </a:solidFill>
@@ -22664,7 +22802,7 @@
               <a:t>Use in AwaazSetu (M2 – Triage):</a:t>
             </a:r>
             <a:r>
-              <a:rPr sz="1400" b="0">
+              <a:rPr sz="1300" b="0">
                 <a:solidFill>
                   <a:srgbClr val="000000"/>
                 </a:solidFill>
@@ -23027,7 +23165,7 @@
                   </a:ext>
                 </a:extLst>
               </a:tr>
-              <a:tr h="2700000">
+              <a:tr h="2250000">
                 <a:tc>
                   <a:txBody>
                     <a:bodyPr/>
@@ -23087,7 +23225,7 @@
                         <a:buNone/>
                       </a:pPr>
                       <a:r>
-                        <a:rPr sz="1300" b="0">
+                        <a:rPr sz="1200" b="0">
                           <a:solidFill>
                             <a:srgbClr val="000000"/>
                           </a:solidFill>
@@ -23099,7 +23237,7 @@
                     </a:p>
                     <a:p>
                       <a:r>
-                        <a:rPr sz="1300" b="0">
+                        <a:rPr sz="1200" b="0">
                           <a:solidFill>
                             <a:srgbClr val="000000"/>
                           </a:solidFill>
@@ -23134,7 +23272,7 @@
                         <a:buNone/>
                       </a:pPr>
                       <a:r>
-                        <a:rPr sz="1300" b="0">
+                        <a:rPr sz="1200" b="0">
                           <a:solidFill>
                             <a:srgbClr val="000000"/>
                           </a:solidFill>
@@ -23146,7 +23284,7 @@
                     </a:p>
                     <a:p>
                       <a:r>
-                        <a:rPr sz="1300" b="0">
+                        <a:rPr sz="1200" b="0">
                           <a:solidFill>
                             <a:srgbClr val="000000"/>
                           </a:solidFill>
@@ -23157,7 +23295,7 @@
                     </a:p>
                     <a:p>
                       <a:r>
-                        <a:rPr sz="1300" b="0">
+                        <a:rPr sz="1200" b="0">
                           <a:solidFill>
                             <a:srgbClr val="000000"/>
                           </a:solidFill>
@@ -23192,7 +23330,7 @@
                         <a:buChar char="•"/>
                       </a:pPr>
                       <a:r>
-                        <a:rPr sz="1300" b="0">
+                        <a:rPr sz="1200" b="0">
                           <a:solidFill>
                             <a:srgbClr val="000000"/>
                           </a:solidFill>
@@ -23208,7 +23346,7 @@
                         <a:buChar char="•"/>
                       </a:pPr>
                       <a:r>
-                        <a:rPr sz="1300" b="0">
+                        <a:rPr sz="1200" b="0">
                           <a:solidFill>
                             <a:srgbClr val="000000"/>
                           </a:solidFill>
@@ -23223,7 +23361,7 @@
                         <a:buChar char="•"/>
                       </a:pPr>
                       <a:r>
-                        <a:rPr sz="1300" b="0">
+                        <a:rPr sz="1200" b="0">
                           <a:solidFill>
                             <a:srgbClr val="000000"/>
                           </a:solidFill>
@@ -23238,7 +23376,7 @@
                         <a:buChar char="•"/>
                       </a:pPr>
                       <a:r>
-                        <a:rPr sz="1300" b="0">
+                        <a:rPr sz="1200" b="0">
                           <a:solidFill>
                             <a:srgbClr val="000000"/>
                           </a:solidFill>
@@ -23451,8 +23589,77 @@
         </p:nvSpPr>
         <p:spPr>
           <a:xfrm>
-            <a:off x="317999" y="5900000"/>
-            <a:ext cx="8454939" cy="560000"/>
+            <a:off x="317999" y="5300000"/>
+            <a:ext cx="8454939" cy="620000"/>
+          </a:xfrm>
+          <a:prstGeom prst="rect">
+            <a:avLst/>
+          </a:prstGeom>
+          <a:solidFill>
+            <a:srgbClr val="EAF1F7"/>
+          </a:solidFill>
+          <a:ln>
+            <a:solidFill>
+              <a:srgbClr val="94B6D2"/>
+            </a:solidFill>
+          </a:ln>
+          <a:effectLst/>
+        </p:spPr>
+        <p:style>
+          <a:lnRef idx="1">
+            <a:schemeClr val="accent1"/>
+          </a:lnRef>
+          <a:fillRef idx="3">
+            <a:schemeClr val="accent1"/>
+          </a:fillRef>
+          <a:effectRef idx="2">
+            <a:schemeClr val="accent1"/>
+          </a:effectRef>
+          <a:fontRef idx="minor">
+            <a:schemeClr val="lt1"/>
+          </a:fontRef>
+        </p:style>
+        <p:txBody>
+          <a:bodyPr rtlCol="0" anchor="ctr" wrap="square"/>
+          <a:lstStyle/>
+          <a:p>
+            <a:pPr algn="l" marL="0" indent="0">
+              <a:spcAft>
+                <a:spcPts val="0"/>
+              </a:spcAft>
+              <a:buNone/>
+            </a:pPr>
+            <a:r>
+              <a:rPr sz="1200" b="1">
+                <a:solidFill>
+                  <a:srgbClr val="000000"/>
+                </a:solidFill>
+                <a:latin typeface="Calibri"/>
+              </a:rPr>
+              <a:t>Dataset(s) used:</a:t>
+            </a:r>
+            <a:r>
+              <a:rPr sz="1200" b="0">
+                <a:solidFill>
+                  <a:srgbClr val="000000"/>
+                </a:solidFill>
+                <a:latin typeface="Calibri"/>
+              </a:rPr>
+              <a:t> Hurricane Harvey (2017) tweets from the authors’ annotated corpus; source: UNT Libraries Harvey Twitter collection · github.com/geoai-lab/HowDoPeopleDescribeLocations.</a:t>
+            </a:r>
+          </a:p>
+        </p:txBody>
+      </p:sp>
+      <p:sp>
+        <p:nvSpPr>
+          <p:cNvPr id="157" name="Rectangle 156"/>
+          <p:cNvSpPr/>
+          <p:nvPr/>
+        </p:nvSpPr>
+        <p:spPr>
+          <a:xfrm>
+            <a:off x="317999" y="6020000"/>
+            <a:ext cx="8454939" cy="520000"/>
           </a:xfrm>
           <a:prstGeom prst="rect">
             <a:avLst/>
@@ -23492,7 +23699,7 @@
               <a:buNone/>
             </a:pPr>
             <a:r>
-              <a:rPr sz="1400" b="1">
+              <a:rPr sz="1300" b="1">
                 <a:solidFill>
                   <a:srgbClr val="000000"/>
                 </a:solidFill>
@@ -23501,7 +23708,7 @@
               <a:t>Use in AwaazSetu (M3 – Location):</a:t>
             </a:r>
             <a:r>
-              <a:rPr sz="1400" b="0">
+              <a:rPr sz="1300" b="0">
                 <a:solidFill>
                   <a:srgbClr val="000000"/>
                 </a:solidFill>
@@ -23864,7 +24071,7 @@
                   </a:ext>
                 </a:extLst>
               </a:tr>
-              <a:tr h="2700000">
+              <a:tr h="2250000">
                 <a:tc>
                   <a:txBody>
                     <a:bodyPr/>
@@ -23924,7 +24131,7 @@
                         <a:buNone/>
                       </a:pPr>
                       <a:r>
-                        <a:rPr sz="1300" b="0">
+                        <a:rPr sz="1200" b="0">
                           <a:solidFill>
                             <a:srgbClr val="000000"/>
                           </a:solidFill>
@@ -23936,7 +24143,7 @@
                     </a:p>
                     <a:p>
                       <a:r>
-                        <a:rPr sz="1300" b="0">
+                        <a:rPr sz="1200" b="0">
                           <a:solidFill>
                             <a:srgbClr val="000000"/>
                           </a:solidFill>
@@ -23971,7 +24178,7 @@
                         <a:buNone/>
                       </a:pPr>
                       <a:r>
-                        <a:rPr sz="1300" b="0">
+                        <a:rPr sz="1200" b="0">
                           <a:solidFill>
                             <a:srgbClr val="000000"/>
                           </a:solidFill>
@@ -23983,7 +24190,7 @@
                     </a:p>
                     <a:p>
                       <a:r>
-                        <a:rPr sz="1300" b="0">
+                        <a:rPr sz="1200" b="0">
                           <a:solidFill>
                             <a:srgbClr val="000000"/>
                           </a:solidFill>
@@ -23994,7 +24201,7 @@
                     </a:p>
                     <a:p>
                       <a:r>
-                        <a:rPr sz="1300" b="0">
+                        <a:rPr sz="1200" b="0">
                           <a:solidFill>
                             <a:srgbClr val="000000"/>
                           </a:solidFill>
@@ -24029,7 +24236,7 @@
                         <a:buChar char="•"/>
                       </a:pPr>
                       <a:r>
-                        <a:rPr sz="1300" b="0">
+                        <a:rPr sz="1200" b="0">
                           <a:solidFill>
                             <a:srgbClr val="000000"/>
                           </a:solidFill>
@@ -24045,7 +24252,7 @@
                         <a:buChar char="•"/>
                       </a:pPr>
                       <a:r>
-                        <a:rPr sz="1300" b="0">
+                        <a:rPr sz="1200" b="0">
                           <a:solidFill>
                             <a:srgbClr val="000000"/>
                           </a:solidFill>
@@ -24060,7 +24267,7 @@
                         <a:buChar char="•"/>
                       </a:pPr>
                       <a:r>
-                        <a:rPr sz="1300" b="0">
+                        <a:rPr sz="1200" b="0">
                           <a:solidFill>
                             <a:srgbClr val="000000"/>
                           </a:solidFill>
@@ -24075,7 +24282,7 @@
                         <a:buChar char="•"/>
                       </a:pPr>
                       <a:r>
-                        <a:rPr sz="1300" b="0">
+                        <a:rPr sz="1200" b="0">
                           <a:solidFill>
                             <a:srgbClr val="000000"/>
                           </a:solidFill>
@@ -24288,8 +24495,77 @@
         </p:nvSpPr>
         <p:spPr>
           <a:xfrm>
-            <a:off x="317999" y="5900000"/>
-            <a:ext cx="8454939" cy="560000"/>
+            <a:off x="317999" y="5300000"/>
+            <a:ext cx="8454939" cy="620000"/>
+          </a:xfrm>
+          <a:prstGeom prst="rect">
+            <a:avLst/>
+          </a:prstGeom>
+          <a:solidFill>
+            <a:srgbClr val="EAF1F7"/>
+          </a:solidFill>
+          <a:ln>
+            <a:solidFill>
+              <a:srgbClr val="94B6D2"/>
+            </a:solidFill>
+          </a:ln>
+          <a:effectLst/>
+        </p:spPr>
+        <p:style>
+          <a:lnRef idx="1">
+            <a:schemeClr val="accent1"/>
+          </a:lnRef>
+          <a:fillRef idx="3">
+            <a:schemeClr val="accent1"/>
+          </a:fillRef>
+          <a:effectRef idx="2">
+            <a:schemeClr val="accent1"/>
+          </a:effectRef>
+          <a:fontRef idx="minor">
+            <a:schemeClr val="lt1"/>
+          </a:fontRef>
+        </p:style>
+        <p:txBody>
+          <a:bodyPr rtlCol="0" anchor="ctr" wrap="square"/>
+          <a:lstStyle/>
+          <a:p>
+            <a:pPr algn="l" marL="0" indent="0">
+              <a:spcAft>
+                <a:spcPts val="0"/>
+              </a:spcAft>
+              <a:buNone/>
+            </a:pPr>
+            <a:r>
+              <a:rPr sz="1200" b="1">
+                <a:solidFill>
+                  <a:srgbClr val="000000"/>
+                </a:solidFill>
+                <a:latin typeface="Calibri"/>
+              </a:rPr>
+              <a:t>Dataset(s) used:</a:t>
+            </a:r>
+            <a:r>
+              <a:rPr sz="1200" b="0">
+                <a:solidFill>
+                  <a:srgbClr val="000000"/>
+                </a:solidFill>
+                <a:latin typeface="Calibri"/>
+              </a:rPr>
+              <a:t> Hurricane Harvey rescue-request tweets (1,807 requests, 534 block groups) + 35 variables from ACS 2015 5-year estimates and CDC/ATSDR SVI, Houston MSA.</a:t>
+            </a:r>
+          </a:p>
+        </p:txBody>
+      </p:sp>
+      <p:sp>
+        <p:nvSpPr>
+          <p:cNvPr id="157" name="Rectangle 156"/>
+          <p:cNvSpPr/>
+          <p:nvPr/>
+        </p:nvSpPr>
+        <p:spPr>
+          <a:xfrm>
+            <a:off x="317999" y="6020000"/>
+            <a:ext cx="8454939" cy="520000"/>
           </a:xfrm>
           <a:prstGeom prst="rect">
             <a:avLst/>
@@ -24329,7 +24605,7 @@
               <a:buNone/>
             </a:pPr>
             <a:r>
-              <a:rPr sz="1400" b="1">
+              <a:rPr sz="1300" b="1">
                 <a:solidFill>
                   <a:srgbClr val="000000"/>
                 </a:solidFill>
@@ -24338,7 +24614,7 @@
               <a:t>Use in AwaazSetu (M4 – Coverage):</a:t>
             </a:r>
             <a:r>
-              <a:rPr sz="1400" b="0">
+              <a:rPr sz="1300" b="0">
                 <a:solidFill>
                   <a:srgbClr val="000000"/>
                 </a:solidFill>

</xml_diff>

<commit_message>
Update guide name and class on CEP submission files
Co-Authored-By: Claude Opus 5.5 <noreply@anthropic.com>
Claude-Session: https://claude.ai/code/session_015D4bQVZNhTGUwEsTWPJArD
</commit_message>
<xml_diff>
--- a/submission/CEP_Review_II_AwaazSetu.pptx
+++ b/submission/CEP_Review_II_AwaazSetu.pptx
@@ -16780,7 +16780,7 @@
                 <a:cs typeface="Tahoma"/>
                 <a:sym typeface="Tahoma"/>
               </a:rPr>
-              <a:t>Prof. Priya Nerkar</a:t>
+              <a:t>Dr. Priya Nerkar</a:t>
             </a:r>
           </a:p>
           <a:p>
@@ -16875,7 +16875,7 @@
                 <a:cs typeface="Tahoma"/>
                 <a:sym typeface="Tahoma"/>
               </a:rPr>
-              <a:t>Second </a:t>
+              <a:t>Second Year B. Tech IT - A</a:t>
             </a:r>
             <a:r>
               <a:rPr lang="en-US" sz="2000" dirty="0" smtClean="0">
@@ -16887,7 +16887,7 @@
                 <a:cs typeface="Tahoma"/>
                 <a:sym typeface="Tahoma"/>
               </a:rPr>
-              <a:t>Year B. Tech </a:t>
+              <a:t/>
             </a:r>
             <a:r>
               <a:rPr lang="en-US" sz="2000" dirty="0">
@@ -16899,7 +16899,7 @@
                 <a:cs typeface="Tahoma"/>
                 <a:sym typeface="Tahoma"/>
               </a:rPr>
-              <a:t>(</a:t>
+              <a:t/>
             </a:r>
             <a:r>
               <a:rPr lang="en-US" sz="2000" dirty="0" err="1">
@@ -16911,7 +16911,7 @@
                 <a:cs typeface="Tahoma"/>
                 <a:sym typeface="Tahoma"/>
               </a:rPr>
-              <a:t>Division</a:t>
+              <a:t/>
             </a:r>
             <a:r>
               <a:rPr lang="en-US" sz="2000" dirty="0">
@@ -16923,7 +16923,7 @@
                 <a:cs typeface="Tahoma"/>
                 <a:sym typeface="Tahoma"/>
               </a:rPr>
-              <a:t>: A</a:t>
+              <a:t/>
             </a:r>
             <a:r>
               <a:rPr lang="en-US" sz="2000" dirty="0" smtClean="0">
@@ -16935,7 +16935,7 @@
                 <a:cs typeface="Tahoma"/>
                 <a:sym typeface="Tahoma"/>
               </a:rPr>
-              <a:t>)</a:t>
+              <a:t/>
             </a:r>
             <a:endParaRPr sz="1400" b="0" i="0" u="none" strike="noStrike" cap="none" dirty="0">
               <a:solidFill>

</xml_diff>